<commit_message>
Add photo frames to country cards slide
Co-Authored-By: Claude Opus 5.5 <noreply@anthropic.com>
Claude-Session: https://claude.ai/code/session_01BHN99WkTUDUfg94JgFGXiz
</commit_message>
<xml_diff>
--- a/workshop1_interior_style.pptx
+++ b/workshop1_interior_style.pptx
@@ -118,42 +118,42 @@
   <p:extLst>
     <p:ext uri="{521415D9-36F7-43E2-AB2F-B90AF26B5E84}">
       <p14:sectionLst xmlns:p14="http://schemas.microsoft.com/office/powerpoint/2010/main">
-        <p14:section name="導入" id="{97838d3f-cad1-773a-307d-e27d76d2af75}">
+        <p14:section name="導入" id="{706de22e-741a-c1d9-b087-bd27bb38ba9a}">
           <p14:sldIdLst>
             <p14:sldId id="256"/>
             <p14:sldId id="257"/>
             <p14:sldId id="258"/>
           </p14:sldIdLst>
         </p14:section>
-        <p14:section name="① オープニング" id="{e4f5e3e3-176d-81b1-db15-5b182c3d9cc2}">
+        <p14:section name="① オープニング" id="{5c822db7-ce42-373b-cf4c-33588e66e254}">
           <p14:sldIdLst>
             <p14:sldId id="259"/>
           </p14:sldIdLst>
         </p14:section>
-        <p14:section name="② デザインの歴史" id="{ac727a13-d36d-c2e0-885b-53705c7985da}">
+        <p14:section name="② デザインの歴史" id="{c0d76e52-2096-f802-a8c5-631a1e2a686e}">
           <p14:sldIdLst>
             <p14:sldId id="260"/>
             <p14:sldId id="261"/>
           </p14:sldIdLst>
         </p14:section>
-        <p14:section name="③ スタイルの特徴" id="{4ce63a2d-6b3a-7242-772e-9edeee651a13}">
+        <p14:section name="③ スタイルの特徴" id="{00dd4f9c-77f1-6fa5-6970-f1139b842e3c}">
           <p14:sldIdLst>
             <p14:sldId id="262"/>
             <p14:sldId id="263"/>
           </p14:sldIdLst>
         </p14:section>
-        <p14:section name="④ 北欧スタイルの定義" id="{13070844-d179-ef86-e493-81dcf3a0e7a3}">
+        <p14:section name="④ 北欧スタイルの定義" id="{9e41b193-fbf6-abc0-f4c2-5c613b1d9ce4}">
           <p14:sldIdLst>
             <p14:sldId id="264"/>
           </p14:sldIdLst>
         </p14:section>
-        <p14:section name="⑤ マトリックス" id="{1d69af56-7c1e-e794-20b8-1ca681adb9cf}">
+        <p14:section name="⑤ マトリックス" id="{d0ab9d0b-2dab-9356-6c5e-079f67747278}">
           <p14:sldIdLst>
             <p14:sldId id="265"/>
             <p14:sldId id="266"/>
           </p14:sldIdLst>
         </p14:section>
-        <p14:section name="⑥ まとめ" id="{2a4372f6-53a9-8511-2878-9376281d6f43}">
+        <p14:section name="⑥ まとめ" id="{4f00ddc1-a73b-ae16-df90-795ba2bdb6a7}">
           <p14:sldIdLst>
             <p14:sldId id="267"/>
           </p14:sldIdLst>
@@ -8586,8 +8586,8 @@
         </p:nvSpPr>
         <p:spPr>
           <a:xfrm>
-            <a:off x="594360" y="2194560"/>
-            <a:ext cx="1280160" cy="2103120"/>
+            <a:off x="594360" y="2148840"/>
+            <a:ext cx="1280160" cy="960120"/>
           </a:xfrm>
           <a:prstGeom prst="rect">
             <a:avLst/>
@@ -8616,7 +8616,96 @@
       </p:sp>
       <p:sp>
         <p:nvSpPr>
-          <p:cNvPr id="8" name="country-1"/>
+          <p:cNvPr id="8" name="photo-0"/>
+          <p:cNvSpPr/>
+          <p:nvPr/>
+        </p:nvSpPr>
+        <p:spPr>
+          <a:xfrm>
+            <a:off x="594360" y="3154680"/>
+            <a:ext cx="1280160" cy="1143000"/>
+          </a:xfrm>
+          <a:prstGeom prst="rect">
+            <a:avLst/>
+          </a:prstGeom>
+          <a:solidFill>
+            <a:schemeClr val="bg1"/>
+          </a:solidFill>
+          <a:ln w="9525">
+            <a:solidFill>
+              <a:srgbClr val="D5DCD7"/>
+            </a:solidFill>
+            <a:prstDash val="dash"/>
+          </a:ln>
+        </p:spPr>
+      </p:sp>
+      <p:sp>
+        <p:nvSpPr>
+          <p:cNvPr id="9" name="photo-label-0"/>
+          <p:cNvSpPr txBox="1"/>
+          <p:nvPr/>
+        </p:nvSpPr>
+        <p:spPr>
+          <a:xfrm>
+            <a:off x="594360" y="3154680"/>
+            <a:ext cx="1280160" cy="1143000"/>
+          </a:xfrm>
+          <a:prstGeom prst="rect">
+            <a:avLst/>
+          </a:prstGeom>
+          <a:noFill/>
+          <a:ln/>
+        </p:spPr>
+        <p:txBody>
+          <a:bodyPr wrap="square" lIns="25400" tIns="25400" rIns="25400" bIns="25400" rtlCol="0" anchor="ctr"/>
+          <a:lstStyle/>
+          <a:p>
+            <a:pPr algn="ctr" indent="0" marL="0">
+              <a:buNone/>
+            </a:pPr>
+            <a:r>
+              <a:rPr lang="en-US" sz="900" dirty="0">
+                <a:solidFill>
+                  <a:schemeClr val="accent6"/>
+                </a:solidFill>
+              </a:rPr>
+              <a:t>写真</a:t>
+            </a:r>
+            <a:endParaRPr lang="en-US" sz="900" dirty="0"/>
+          </a:p>
+          <a:p>
+            <a:pPr algn="ctr" indent="0" marL="0">
+              <a:buNone/>
+            </a:pPr>
+            <a:r>
+              <a:rPr lang="en-US" sz="900" dirty="0">
+                <a:solidFill>
+                  <a:schemeClr val="accent6"/>
+                </a:solidFill>
+              </a:rPr>
+              <a:t>ヴェルサイユ宮殿</a:t>
+            </a:r>
+            <a:endParaRPr lang="en-US" sz="900" dirty="0"/>
+          </a:p>
+          <a:p>
+            <a:pPr algn="ctr" indent="0" marL="0">
+              <a:buNone/>
+            </a:pPr>
+            <a:r>
+              <a:rPr lang="en-US" sz="900" dirty="0">
+                <a:solidFill>
+                  <a:schemeClr val="accent6"/>
+                </a:solidFill>
+              </a:rPr>
+              <a:t>鏡の間</a:t>
+            </a:r>
+            <a:endParaRPr lang="en-US" sz="900" dirty="0"/>
+          </a:p>
+        </p:txBody>
+      </p:sp>
+      <p:sp>
+        <p:nvSpPr>
+          <p:cNvPr id="10" name="country-1"/>
           <p:cNvSpPr/>
           <p:nvPr/>
         </p:nvSpPr>
@@ -8638,7 +8727,7 @@
       </p:sp>
       <p:sp>
         <p:nvSpPr>
-          <p:cNvPr id="9" name="Text 7"/>
+          <p:cNvPr id="11" name="Text 9"/>
           <p:cNvSpPr txBox="1"/>
           <p:nvPr/>
         </p:nvSpPr>
@@ -8674,7 +8763,7 @@
       </p:sp>
       <p:sp>
         <p:nvSpPr>
-          <p:cNvPr id="10" name="Text 8"/>
+          <p:cNvPr id="12" name="Text 10"/>
           <p:cNvSpPr txBox="1"/>
           <p:nvPr/>
         </p:nvSpPr>
@@ -8710,14 +8799,14 @@
       </p:sp>
       <p:sp>
         <p:nvSpPr>
-          <p:cNvPr id="11" name="Text 9"/>
+          <p:cNvPr id="13" name="Text 11"/>
           <p:cNvSpPr txBox="1"/>
           <p:nvPr/>
         </p:nvSpPr>
         <p:spPr>
           <a:xfrm>
-            <a:off x="2276856" y="2194560"/>
-            <a:ext cx="1280160" cy="2103120"/>
+            <a:off x="2276856" y="2148840"/>
+            <a:ext cx="1280160" cy="960120"/>
           </a:xfrm>
           <a:prstGeom prst="rect">
             <a:avLst/>
@@ -8746,7 +8835,96 @@
       </p:sp>
       <p:sp>
         <p:nvSpPr>
-          <p:cNvPr id="12" name="country-2"/>
+          <p:cNvPr id="14" name="photo-1"/>
+          <p:cNvSpPr/>
+          <p:nvPr/>
+        </p:nvSpPr>
+        <p:spPr>
+          <a:xfrm>
+            <a:off x="2276856" y="3154680"/>
+            <a:ext cx="1280160" cy="1143000"/>
+          </a:xfrm>
+          <a:prstGeom prst="rect">
+            <a:avLst/>
+          </a:prstGeom>
+          <a:solidFill>
+            <a:schemeClr val="bg1"/>
+          </a:solidFill>
+          <a:ln w="9525">
+            <a:solidFill>
+              <a:srgbClr val="D5DCD7"/>
+            </a:solidFill>
+            <a:prstDash val="dash"/>
+          </a:ln>
+        </p:spPr>
+      </p:sp>
+      <p:sp>
+        <p:nvSpPr>
+          <p:cNvPr id="15" name="photo-label-1"/>
+          <p:cNvSpPr txBox="1"/>
+          <p:nvPr/>
+        </p:nvSpPr>
+        <p:spPr>
+          <a:xfrm>
+            <a:off x="2276856" y="3154680"/>
+            <a:ext cx="1280160" cy="1143000"/>
+          </a:xfrm>
+          <a:prstGeom prst="rect">
+            <a:avLst/>
+          </a:prstGeom>
+          <a:noFill/>
+          <a:ln/>
+        </p:spPr>
+        <p:txBody>
+          <a:bodyPr wrap="square" lIns="25400" tIns="25400" rIns="25400" bIns="25400" rtlCol="0" anchor="ctr"/>
+          <a:lstStyle/>
+          <a:p>
+            <a:pPr algn="ctr" indent="0" marL="0">
+              <a:buNone/>
+            </a:pPr>
+            <a:r>
+              <a:rPr lang="en-US" sz="900" dirty="0">
+                <a:solidFill>
+                  <a:schemeClr val="accent6"/>
+                </a:solidFill>
+              </a:rPr>
+              <a:t>写真</a:t>
+            </a:r>
+            <a:endParaRPr lang="en-US" sz="900" dirty="0"/>
+          </a:p>
+          <a:p>
+            <a:pPr algn="ctr" indent="0" marL="0">
+              <a:buNone/>
+            </a:pPr>
+            <a:r>
+              <a:rPr lang="en-US" sz="900" dirty="0">
+                <a:solidFill>
+                  <a:schemeClr val="accent6"/>
+                </a:solidFill>
+              </a:rPr>
+              <a:t>ジオ・ポンティ</a:t>
+            </a:r>
+            <a:endParaRPr lang="en-US" sz="900" dirty="0"/>
+          </a:p>
+          <a:p>
+            <a:pPr algn="ctr" indent="0" marL="0">
+              <a:buNone/>
+            </a:pPr>
+            <a:r>
+              <a:rPr lang="en-US" sz="900" dirty="0">
+                <a:solidFill>
+                  <a:schemeClr val="accent6"/>
+                </a:solidFill>
+              </a:rPr>
+              <a:t>スーパーレジェーラ</a:t>
+            </a:r>
+            <a:endParaRPr lang="en-US" sz="900" dirty="0"/>
+          </a:p>
+        </p:txBody>
+      </p:sp>
+      <p:sp>
+        <p:nvSpPr>
+          <p:cNvPr id="16" name="country-2"/>
           <p:cNvSpPr/>
           <p:nvPr/>
         </p:nvSpPr>
@@ -8768,7 +8946,7 @@
       </p:sp>
       <p:sp>
         <p:nvSpPr>
-          <p:cNvPr id="13" name="Text 11"/>
+          <p:cNvPr id="17" name="Text 15"/>
           <p:cNvSpPr txBox="1"/>
           <p:nvPr/>
         </p:nvSpPr>
@@ -8804,7 +8982,7 @@
       </p:sp>
       <p:sp>
         <p:nvSpPr>
-          <p:cNvPr id="14" name="Text 12"/>
+          <p:cNvPr id="18" name="Text 16"/>
           <p:cNvSpPr txBox="1"/>
           <p:nvPr/>
         </p:nvSpPr>
@@ -8840,14 +9018,14 @@
       </p:sp>
       <p:sp>
         <p:nvSpPr>
-          <p:cNvPr id="15" name="Text 13"/>
+          <p:cNvPr id="19" name="Text 17"/>
           <p:cNvSpPr txBox="1"/>
           <p:nvPr/>
         </p:nvSpPr>
         <p:spPr>
           <a:xfrm>
-            <a:off x="3959352" y="2194560"/>
-            <a:ext cx="1280160" cy="2103120"/>
+            <a:off x="3959352" y="2148840"/>
+            <a:ext cx="1280160" cy="960120"/>
           </a:xfrm>
           <a:prstGeom prst="rect">
             <a:avLst/>
@@ -8876,7 +9054,96 @@
       </p:sp>
       <p:sp>
         <p:nvSpPr>
-          <p:cNvPr id="16" name="country-3"/>
+          <p:cNvPr id="20" name="photo-2"/>
+          <p:cNvSpPr/>
+          <p:nvPr/>
+        </p:nvSpPr>
+        <p:spPr>
+          <a:xfrm>
+            <a:off x="3959352" y="3154680"/>
+            <a:ext cx="1280160" cy="1143000"/>
+          </a:xfrm>
+          <a:prstGeom prst="rect">
+            <a:avLst/>
+          </a:prstGeom>
+          <a:solidFill>
+            <a:schemeClr val="bg1"/>
+          </a:solidFill>
+          <a:ln w="9525">
+            <a:solidFill>
+              <a:srgbClr val="D5DCD7"/>
+            </a:solidFill>
+            <a:prstDash val="dash"/>
+          </a:ln>
+        </p:spPr>
+      </p:sp>
+      <p:sp>
+        <p:nvSpPr>
+          <p:cNvPr id="21" name="photo-label-2"/>
+          <p:cNvSpPr txBox="1"/>
+          <p:nvPr/>
+        </p:nvSpPr>
+        <p:spPr>
+          <a:xfrm>
+            <a:off x="3959352" y="3154680"/>
+            <a:ext cx="1280160" cy="1143000"/>
+          </a:xfrm>
+          <a:prstGeom prst="rect">
+            <a:avLst/>
+          </a:prstGeom>
+          <a:noFill/>
+          <a:ln/>
+        </p:spPr>
+        <p:txBody>
+          <a:bodyPr wrap="square" lIns="25400" tIns="25400" rIns="25400" bIns="25400" rtlCol="0" anchor="ctr"/>
+          <a:lstStyle/>
+          <a:p>
+            <a:pPr algn="ctr" indent="0" marL="0">
+              <a:buNone/>
+            </a:pPr>
+            <a:r>
+              <a:rPr lang="en-US" sz="900" dirty="0">
+                <a:solidFill>
+                  <a:schemeClr val="accent6"/>
+                </a:solidFill>
+              </a:rPr>
+              <a:t>写真</a:t>
+            </a:r>
+            <a:endParaRPr lang="en-US" sz="900" dirty="0"/>
+          </a:p>
+          <a:p>
+            <a:pPr algn="ctr" indent="0" marL="0">
+              <a:buNone/>
+            </a:pPr>
+            <a:r>
+              <a:rPr lang="en-US" sz="900" dirty="0">
+                <a:solidFill>
+                  <a:schemeClr val="accent6"/>
+                </a:solidFill>
+              </a:rPr>
+              <a:t>ウィリアム・モリス</a:t>
+            </a:r>
+            <a:endParaRPr lang="en-US" sz="900" dirty="0"/>
+          </a:p>
+          <a:p>
+            <a:pPr algn="ctr" indent="0" marL="0">
+              <a:buNone/>
+            </a:pPr>
+            <a:r>
+              <a:rPr lang="en-US" sz="900" dirty="0">
+                <a:solidFill>
+                  <a:schemeClr val="accent6"/>
+                </a:solidFill>
+              </a:rPr>
+              <a:t>のテキスタイル</a:t>
+            </a:r>
+            <a:endParaRPr lang="en-US" sz="900" dirty="0"/>
+          </a:p>
+        </p:txBody>
+      </p:sp>
+      <p:sp>
+        <p:nvSpPr>
+          <p:cNvPr id="22" name="country-3"/>
           <p:cNvSpPr/>
           <p:nvPr/>
         </p:nvSpPr>
@@ -8898,7 +9165,7 @@
       </p:sp>
       <p:sp>
         <p:nvSpPr>
-          <p:cNvPr id="17" name="Text 15"/>
+          <p:cNvPr id="23" name="Text 21"/>
           <p:cNvSpPr txBox="1"/>
           <p:nvPr/>
         </p:nvSpPr>
@@ -8934,7 +9201,7 @@
       </p:sp>
       <p:sp>
         <p:nvSpPr>
-          <p:cNvPr id="18" name="Text 16"/>
+          <p:cNvPr id="24" name="Text 22"/>
           <p:cNvSpPr txBox="1"/>
           <p:nvPr/>
         </p:nvSpPr>
@@ -8970,14 +9237,14 @@
       </p:sp>
       <p:sp>
         <p:nvSpPr>
-          <p:cNvPr id="19" name="Text 17"/>
+          <p:cNvPr id="25" name="Text 23"/>
           <p:cNvSpPr txBox="1"/>
           <p:nvPr/>
         </p:nvSpPr>
         <p:spPr>
           <a:xfrm>
-            <a:off x="5641848" y="2194560"/>
-            <a:ext cx="1280160" cy="2103120"/>
+            <a:off x="5641848" y="2148840"/>
+            <a:ext cx="1280160" cy="960120"/>
           </a:xfrm>
           <a:prstGeom prst="rect">
             <a:avLst/>
@@ -9006,7 +9273,96 @@
       </p:sp>
       <p:sp>
         <p:nvSpPr>
-          <p:cNvPr id="20" name="country-4"/>
+          <p:cNvPr id="26" name="photo-3"/>
+          <p:cNvSpPr/>
+          <p:nvPr/>
+        </p:nvSpPr>
+        <p:spPr>
+          <a:xfrm>
+            <a:off x="5641848" y="3154680"/>
+            <a:ext cx="1280160" cy="1143000"/>
+          </a:xfrm>
+          <a:prstGeom prst="rect">
+            <a:avLst/>
+          </a:prstGeom>
+          <a:solidFill>
+            <a:schemeClr val="bg1"/>
+          </a:solidFill>
+          <a:ln w="9525">
+            <a:solidFill>
+              <a:srgbClr val="D5DCD7"/>
+            </a:solidFill>
+            <a:prstDash val="dash"/>
+          </a:ln>
+        </p:spPr>
+      </p:sp>
+      <p:sp>
+        <p:nvSpPr>
+          <p:cNvPr id="27" name="photo-label-3"/>
+          <p:cNvSpPr txBox="1"/>
+          <p:nvPr/>
+        </p:nvSpPr>
+        <p:spPr>
+          <a:xfrm>
+            <a:off x="5641848" y="3154680"/>
+            <a:ext cx="1280160" cy="1143000"/>
+          </a:xfrm>
+          <a:prstGeom prst="rect">
+            <a:avLst/>
+          </a:prstGeom>
+          <a:noFill/>
+          <a:ln/>
+        </p:spPr>
+        <p:txBody>
+          <a:bodyPr wrap="square" lIns="25400" tIns="25400" rIns="25400" bIns="25400" rtlCol="0" anchor="ctr"/>
+          <a:lstStyle/>
+          <a:p>
+            <a:pPr algn="ctr" indent="0" marL="0">
+              <a:buNone/>
+            </a:pPr>
+            <a:r>
+              <a:rPr lang="en-US" sz="900" dirty="0">
+                <a:solidFill>
+                  <a:schemeClr val="accent6"/>
+                </a:solidFill>
+              </a:rPr>
+              <a:t>写真</a:t>
+            </a:r>
+            <a:endParaRPr lang="en-US" sz="900" dirty="0"/>
+          </a:p>
+          <a:p>
+            <a:pPr algn="ctr" indent="0" marL="0">
+              <a:buNone/>
+            </a:pPr>
+            <a:r>
+              <a:rPr lang="en-US" sz="900" dirty="0">
+                <a:solidFill>
+                  <a:schemeClr val="accent6"/>
+                </a:solidFill>
+              </a:rPr>
+              <a:t>ブロイヤー</a:t>
+            </a:r>
+            <a:endParaRPr lang="en-US" sz="900" dirty="0"/>
+          </a:p>
+          <a:p>
+            <a:pPr algn="ctr" indent="0" marL="0">
+              <a:buNone/>
+            </a:pPr>
+            <a:r>
+              <a:rPr lang="en-US" sz="900" dirty="0">
+                <a:solidFill>
+                  <a:schemeClr val="accent6"/>
+                </a:solidFill>
+              </a:rPr>
+              <a:t>ワシリーチェア</a:t>
+            </a:r>
+            <a:endParaRPr lang="en-US" sz="900" dirty="0"/>
+          </a:p>
+        </p:txBody>
+      </p:sp>
+      <p:sp>
+        <p:nvSpPr>
+          <p:cNvPr id="28" name="country-4"/>
           <p:cNvSpPr/>
           <p:nvPr/>
         </p:nvSpPr>
@@ -9028,7 +9384,7 @@
       </p:sp>
       <p:sp>
         <p:nvSpPr>
-          <p:cNvPr id="21" name="Text 19"/>
+          <p:cNvPr id="29" name="Text 27"/>
           <p:cNvSpPr txBox="1"/>
           <p:nvPr/>
         </p:nvSpPr>
@@ -9064,7 +9420,7 @@
       </p:sp>
       <p:sp>
         <p:nvSpPr>
-          <p:cNvPr id="22" name="Text 20"/>
+          <p:cNvPr id="30" name="Text 28"/>
           <p:cNvSpPr txBox="1"/>
           <p:nvPr/>
         </p:nvSpPr>
@@ -9100,14 +9456,14 @@
       </p:sp>
       <p:sp>
         <p:nvSpPr>
-          <p:cNvPr id="23" name="Text 21"/>
+          <p:cNvPr id="31" name="Text 29"/>
           <p:cNvSpPr txBox="1"/>
           <p:nvPr/>
         </p:nvSpPr>
         <p:spPr>
           <a:xfrm>
-            <a:off x="7324344" y="2194560"/>
-            <a:ext cx="1280160" cy="2103120"/>
+            <a:off x="7324344" y="2148840"/>
+            <a:ext cx="1280160" cy="960120"/>
           </a:xfrm>
           <a:prstGeom prst="rect">
             <a:avLst/>
@@ -9131,6 +9487,95 @@
               <a:t>室内で過ごす時間が長い。木の温もり、明るさ、使いやすさ</a:t>
             </a:r>
             <a:endParaRPr lang="en-US" sz="1200" dirty="0"/>
+          </a:p>
+        </p:txBody>
+      </p:sp>
+      <p:sp>
+        <p:nvSpPr>
+          <p:cNvPr id="32" name="photo-4"/>
+          <p:cNvSpPr/>
+          <p:nvPr/>
+        </p:nvSpPr>
+        <p:spPr>
+          <a:xfrm>
+            <a:off x="7324344" y="3154680"/>
+            <a:ext cx="1280160" cy="1143000"/>
+          </a:xfrm>
+          <a:prstGeom prst="rect">
+            <a:avLst/>
+          </a:prstGeom>
+          <a:solidFill>
+            <a:schemeClr val="bg1"/>
+          </a:solidFill>
+          <a:ln w="9525">
+            <a:solidFill>
+              <a:srgbClr val="D5DCD7"/>
+            </a:solidFill>
+            <a:prstDash val="dash"/>
+          </a:ln>
+        </p:spPr>
+      </p:sp>
+      <p:sp>
+        <p:nvSpPr>
+          <p:cNvPr id="33" name="photo-label-4"/>
+          <p:cNvSpPr txBox="1"/>
+          <p:nvPr/>
+        </p:nvSpPr>
+        <p:spPr>
+          <a:xfrm>
+            <a:off x="7324344" y="3154680"/>
+            <a:ext cx="1280160" cy="1143000"/>
+          </a:xfrm>
+          <a:prstGeom prst="rect">
+            <a:avLst/>
+          </a:prstGeom>
+          <a:noFill/>
+          <a:ln/>
+        </p:spPr>
+        <p:txBody>
+          <a:bodyPr wrap="square" lIns="25400" tIns="25400" rIns="25400" bIns="25400" rtlCol="0" anchor="ctr"/>
+          <a:lstStyle/>
+          <a:p>
+            <a:pPr algn="ctr" indent="0" marL="0">
+              <a:buNone/>
+            </a:pPr>
+            <a:r>
+              <a:rPr lang="en-US" sz="900" dirty="0">
+                <a:solidFill>
+                  <a:schemeClr val="accent6"/>
+                </a:solidFill>
+              </a:rPr>
+              <a:t>写真</a:t>
+            </a:r>
+            <a:endParaRPr lang="en-US" sz="900" dirty="0"/>
+          </a:p>
+          <a:p>
+            <a:pPr algn="ctr" indent="0" marL="0">
+              <a:buNone/>
+            </a:pPr>
+            <a:r>
+              <a:rPr lang="en-US" sz="900" dirty="0">
+                <a:solidFill>
+                  <a:schemeClr val="accent6"/>
+                </a:solidFill>
+              </a:rPr>
+              <a:t>ウェグナー</a:t>
+            </a:r>
+            <a:endParaRPr lang="en-US" sz="900" dirty="0"/>
+          </a:p>
+          <a:p>
+            <a:pPr algn="ctr" indent="0" marL="0">
+              <a:buNone/>
+            </a:pPr>
+            <a:r>
+              <a:rPr lang="en-US" sz="900" dirty="0">
+                <a:solidFill>
+                  <a:schemeClr val="accent6"/>
+                </a:solidFill>
+              </a:rPr>
+              <a:t>Yチェア</a:t>
+            </a:r>
+            <a:endParaRPr lang="en-US" sz="900" dirty="0"/>
           </a:p>
         </p:txBody>
       </p:sp>

</xml_diff>

<commit_message>
Lighten opening slides and list data sources with links
Co-Authored-By: Claude Opus 5.5 <noreply@anthropic.com>
Claude-Session: https://claude.ai/code/session_01BHN99WkTUDUfg94JgFGXiz
</commit_message>
<xml_diff>
--- a/workshop1_interior_style.pptx
+++ b/workshop1_interior_style.pptx
@@ -121,7 +121,7 @@
   <p:extLst>
     <p:ext uri="{521415D9-36F7-43E2-AB2F-B90AF26B5E84}">
       <p14:sectionLst xmlns:p14="http://schemas.microsoft.com/office/powerpoint/2010/main">
-        <p14:section name="導入" id="{153ea0c9-30f7-847d-a13b-ffd7fcf10581}">
+        <p14:section name="導入" id="{a715fe0f-6d07-fb99-a6b2-a62e00c0adc2}">
           <p14:sldIdLst>
             <p14:sldId id="256"/>
             <p14:sldId id="257"/>
@@ -130,36 +130,36 @@
             <p14:sldId id="260"/>
           </p14:sldIdLst>
         </p14:section>
-        <p14:section name="① オープニング" id="{216c11b9-07d1-3815-6f87-ad483324eec5}">
+        <p14:section name="① オープニング" id="{b2fb76ef-2485-3ecd-d29d-7c971fa85012}">
           <p14:sldIdLst>
             <p14:sldId id="261"/>
           </p14:sldIdLst>
         </p14:section>
-        <p14:section name="② デザインの歴史" id="{3fd09af7-31b6-e984-6a0f-f90397f73dad}">
+        <p14:section name="② デザインの歴史" id="{32c0597f-edad-785a-7363-ae2371ceb3df}">
           <p14:sldIdLst>
             <p14:sldId id="262"/>
             <p14:sldId id="263"/>
             <p14:sldId id="264"/>
           </p14:sldIdLst>
         </p14:section>
-        <p14:section name="③ スタイルの特徴" id="{d7e1c1ca-650d-3555-f09a-cd5719c48ec6}">
+        <p14:section name="③ スタイルの特徴" id="{9bdb4e47-927b-b7f1-46d6-d2716035de21}">
           <p14:sldIdLst>
             <p14:sldId id="265"/>
             <p14:sldId id="266"/>
           </p14:sldIdLst>
         </p14:section>
-        <p14:section name="④ 北欧スタイルの定義" id="{a86613d6-9767-417b-80da-90bb10a125e5}">
+        <p14:section name="④ 北欧スタイルの定義" id="{48338da0-c243-ab5a-0760-a6d34fbff339}">
           <p14:sldIdLst>
             <p14:sldId id="267"/>
           </p14:sldIdLst>
         </p14:section>
-        <p14:section name="⑤ マトリックス" id="{77b45753-c78a-4683-a68b-fac118b8edd2}">
+        <p14:section name="⑤ マトリックス" id="{057c0f8c-7037-f526-20c8-4fd16424fd83}">
           <p14:sldIdLst>
             <p14:sldId id="268"/>
             <p14:sldId id="269"/>
           </p14:sldIdLst>
         </p14:section>
-        <p14:section name="⑥ まとめ" id="{7e532d22-6d5b-5814-8d3d-98125fd807cb}">
+        <p14:section name="⑥ まとめ" id="{f55e73dc-baa3-93c9-1bc2-5c8f4fb5fb01}">
           <p14:sldIdLst>
             <p14:sldId id="270"/>
           </p14:sldIdLst>
@@ -1984,6 +1984,116 @@
 
 <file path=ppt/slideLayouts/slideLayout3.xml><?xml version="1.0" encoding="utf-8"?>
 <p:sldLayout xmlns:a="http://schemas.openxmlformats.org/drawingml/2006/main" xmlns:r="http://schemas.openxmlformats.org/officeDocument/2006/relationships" xmlns:p="http://schemas.openxmlformats.org/presentationml/2006/main" preserve="1">
+  <p:cSld name="LIGHT">
+    <p:bg>
+      <p:bgPr>
+        <a:solidFill>
+          <a:schemeClr val="bg2"/>
+        </a:solidFill>
+      </p:bgPr>
+    </p:bg>
+    <p:spTree>
+      <p:nvGrpSpPr>
+        <p:cNvPr id="1" name=""/>
+        <p:cNvGrpSpPr/>
+        <p:nvPr/>
+      </p:nvGrpSpPr>
+      <p:grpSpPr>
+        <a:xfrm>
+          <a:off x="0" y="0"/>
+          <a:ext cx="0" cy="0"/>
+          <a:chOff x="0" y="0"/>
+          <a:chExt cx="0" cy="0"/>
+        </a:xfrm>
+      </p:grpSpPr>
+      <p:sp>
+        <p:nvSpPr>
+          <p:cNvPr id="2" name="Text 0"/>
+          <p:cNvSpPr/>
+          <p:nvPr>
+            <p:ph idx="100" type="title" hasCustomPrompt="1"/>
+          </p:nvPr>
+        </p:nvSpPr>
+        <p:spPr>
+          <a:xfrm>
+            <a:off x="640080" y="1188720"/>
+            <a:ext cx="7863840" cy="1463040"/>
+          </a:xfrm>
+          <a:prstGeom prst="rect">
+            <a:avLst/>
+          </a:prstGeom>
+          <a:noFill/>
+          <a:ln/>
+        </p:spPr>
+        <p:txBody>
+          <a:bodyPr wrap="square" rtlCol="0"/>
+          <a:lstStyle>
+            <a:lvl1pPr algn="l" indent="0" marL="0">
+              <a:buNone/>
+              <a:defRPr lang="en-US" sz="3600" b="1" dirty="0">
+                <a:solidFill>
+                  <a:schemeClr val="tx2"/>
+                </a:solidFill>
+              </a:defRPr>
+            </a:lvl1pPr>
+          </a:lstStyle>
+          <a:p>
+            <a:pPr algn="l" indent="0" marL="0">
+              <a:buNone/>
+            </a:pPr>
+            <a:endParaRPr lang="en-US" sz="3600" dirty="0"/>
+          </a:p>
+        </p:txBody>
+      </p:sp>
+      <p:sp>
+        <p:nvSpPr>
+          <p:cNvPr id="3" name="Text 0"/>
+          <p:cNvSpPr/>
+          <p:nvPr>
+            <p:ph idx="101" type="body" hasCustomPrompt="1"/>
+          </p:nvPr>
+        </p:nvSpPr>
+        <p:spPr>
+          <a:xfrm>
+            <a:off x="640080" y="2834640"/>
+            <a:ext cx="7863840" cy="1645920"/>
+          </a:xfrm>
+          <a:prstGeom prst="rect">
+            <a:avLst/>
+          </a:prstGeom>
+          <a:noFill/>
+          <a:ln/>
+        </p:spPr>
+        <p:txBody>
+          <a:bodyPr wrap="square" rtlCol="0"/>
+          <a:lstStyle>
+            <a:lvl1pPr algn="l" indent="0" marL="0">
+              <a:buNone/>
+              <a:defRPr lang="en-US" sz="1600" dirty="0">
+                <a:solidFill>
+                  <a:schemeClr val="accent6"/>
+                </a:solidFill>
+              </a:defRPr>
+            </a:lvl1pPr>
+          </a:lstStyle>
+          <a:p>
+            <a:pPr algn="l" indent="0" marL="0">
+              <a:buNone/>
+            </a:pPr>
+            <a:endParaRPr lang="en-US" sz="1600" dirty="0"/>
+          </a:p>
+        </p:txBody>
+      </p:sp>
+    </p:spTree>
+  </p:cSld>
+  <p:clrMapOvr>
+    <a:masterClrMapping/>
+  </p:clrMapOvr>
+</p:sldLayout>
+</file>
+
+<file path=ppt/slideLayouts/slideLayout4.xml><?xml version="1.0" encoding="utf-8"?>
+<p:sldLayout xmlns:a="http://schemas.openxmlformats.org/drawingml/2006/main" xmlns:r="http://schemas.openxmlformats.org/officeDocument/2006/relationships" xmlns:p="http://schemas.openxmlformats.org/presentationml/2006/main" preserve="1">
   <p:cSld name="CONTENT">
     <p:bg>
       <p:bgPr>
@@ -2084,7 +2194,7 @@
             <a:pPr algn="l"/>
             <a:fld id="{F7021451-1387-4CA6-816F-3879F97B5CBC}" type="slidenum">
               <a:rPr b="0" lang="en-US"/>
-              <a:t>1003</a:t>
+              <a:t>1004</a:t>
             </a:fld>
             <a:endParaRPr lang="en-US"/>
           </a:p>
@@ -2167,6 +2277,7 @@
     <p:sldLayoutId id="2147483649" r:id="rId1"/>
     <p:sldLayoutId id="2147483650" r:id="rId2"/>
     <p:sldLayoutId id="2147483651" r:id="rId3"/>
+    <p:sldLayoutId id="2147483652" r:id="rId4"/>
   </p:sldLayoutIdLst>
   <p:hf sldNum="0" hdr="0" ftr="0" dt="0"/>
   <p:txStyles>
@@ -2441,7 +2552,47 @@
       </p:grpSpPr>
       <p:sp>
         <p:nvSpPr>
-          <p:cNvPr id="2" name="Text 0"/>
+          <p:cNvPr id="2" name="motif-large"/>
+          <p:cNvSpPr/>
+          <p:nvPr/>
+        </p:nvSpPr>
+        <p:spPr>
+          <a:xfrm>
+            <a:off x="6400800" y="320040"/>
+            <a:ext cx="2011680" cy="2011680"/>
+          </a:xfrm>
+          <a:prstGeom prst="ellipse">
+            <a:avLst/>
+          </a:prstGeom>
+          <a:solidFill>
+            <a:schemeClr val="accent5"/>
+          </a:solidFill>
+          <a:ln/>
+        </p:spPr>
+      </p:sp>
+      <p:sp>
+        <p:nvSpPr>
+          <p:cNvPr id="3" name="motif-small"/>
+          <p:cNvSpPr/>
+          <p:nvPr/>
+        </p:nvSpPr>
+        <p:spPr>
+          <a:xfrm>
+            <a:off x="7680960" y="1600200"/>
+            <a:ext cx="914400" cy="914400"/>
+          </a:xfrm>
+          <a:prstGeom prst="ellipse">
+            <a:avLst/>
+          </a:prstGeom>
+          <a:solidFill>
+            <a:schemeClr val="accent3"/>
+          </a:solidFill>
+          <a:ln/>
+        </p:spPr>
+      </p:sp>
+      <p:sp>
+        <p:nvSpPr>
+          <p:cNvPr id="4" name="Text 0"/>
           <p:cNvSpPr/>
           <p:nvPr>
             <p:ph idx="100" type="title" hasCustomPrompt="1"/>
@@ -2468,7 +2619,7 @@
             <a:r>
               <a:rPr lang="en-US" sz="3600" b="1" dirty="0">
                 <a:solidFill>
-                  <a:schemeClr val="bg1"/>
+                  <a:schemeClr val="tx2"/>
                 </a:solidFill>
               </a:rPr>
               <a:t>インテリアスタイルを知る</a:t>
@@ -2479,7 +2630,7 @@
       </p:sp>
       <p:sp>
         <p:nvSpPr>
-          <p:cNvPr id="3" name="Text 0"/>
+          <p:cNvPr id="5" name="Text 0"/>
           <p:cNvSpPr/>
           <p:nvPr>
             <p:ph idx="101" type="body" hasCustomPrompt="1"/>
@@ -2506,7 +2657,7 @@
             <a:r>
               <a:rPr lang="en-US" sz="1600" dirty="0">
                 <a:solidFill>
-                  <a:schemeClr val="bg2"/>
+                  <a:schemeClr val="accent6"/>
                 </a:solidFill>
               </a:rPr>
               <a:t>ワークショップ①　スタイルには背景がある　｜　90分</a:t>
@@ -2514,26 +2665,6 @@
             <a:endParaRPr lang="en-US" sz="1600" dirty="0"/>
           </a:p>
         </p:txBody>
-      </p:sp>
-      <p:sp>
-        <p:nvSpPr>
-          <p:cNvPr id="4" name="motif"/>
-          <p:cNvSpPr/>
-          <p:nvPr/>
-        </p:nvSpPr>
-        <p:spPr>
-          <a:xfrm>
-            <a:off x="7498080" y="457200"/>
-            <a:ext cx="1097280" cy="1097280"/>
-          </a:xfrm>
-          <a:prstGeom prst="ellipse">
-            <a:avLst/>
-          </a:prstGeom>
-          <a:solidFill>
-            <a:schemeClr val="accent1"/>
-          </a:solidFill>
-          <a:ln/>
-        </p:spPr>
       </p:sp>
     </p:spTree>
   </p:cSld>
@@ -7595,7 +7726,7 @@
         </p:nvSpPr>
         <p:spPr>
           <a:xfrm>
-            <a:off x="457200" y="3154680"/>
+            <a:off x="457200" y="3108960"/>
             <a:ext cx="8229600" cy="685800"/>
           </a:xfrm>
           <a:prstGeom prst="rect">
@@ -7673,14 +7804,14 @@
       </p:sp>
       <p:sp>
         <p:nvSpPr>
-          <p:cNvPr id="17" name="Text 15"/>
+          <p:cNvPr id="17" name="sources"/>
           <p:cNvSpPr txBox="1"/>
           <p:nvPr/>
         </p:nvSpPr>
         <p:spPr>
           <a:xfrm>
-            <a:off x="457200" y="4160520"/>
-            <a:ext cx="7772400" cy="411480"/>
+            <a:off x="457200" y="3840480"/>
+            <a:ext cx="7863840" cy="914400"/>
           </a:xfrm>
           <a:prstGeom prst="rect">
             <a:avLst/>
@@ -7696,14 +7827,98 @@
               <a:buNone/>
             </a:pPr>
             <a:r>
-              <a:rPr lang="en-US" sz="900" dirty="0">
+              <a:rPr lang="en-US" sz="1000" b="1" dirty="0">
+                <a:solidFill>
+                  <a:schemeClr val="tx2"/>
+                </a:solidFill>
+              </a:rPr>
+              <a:t>出典</a:t>
+            </a:r>
+            <a:endParaRPr lang="en-US" sz="1000" dirty="0"/>
+          </a:p>
+          <a:p>
+            <a:pPr indent="0" marL="0">
+              <a:buNone/>
+            </a:pPr>
+            <a:r>
+              <a:rPr lang="en-US" sz="1000" u="sng" dirty="0">
                 <a:solidFill>
                   <a:schemeClr val="accent6"/>
                 </a:solidFill>
-              </a:rPr>
-              <a:t>出典：一条工務店「住まいのインテリアに関する意識調査」2022年／「自宅のインテリアに関する意識調査」2024年（766人）・2025年、マイボイスコム「インテリアに関するアンケート調査」2025年6月</a:t>
-            </a:r>
-            <a:endParaRPr lang="en-US" sz="900" dirty="0"/>
+                <a:hlinkClick r:id="rId1" invalidUrl="" action="" tgtFrame="" tooltip="" history="1" highlightClick="0" endSnd="0">
+                  <a:extLst>
+                    <a:ext uri="{A12FA001-AC4F-418D-AE19-62706E023703}">
+                      <ahyp:hlinkClr xmlns:ahyp="http://schemas.microsoft.com/office/drawing/2018/hyperlinkcolor" val="tx"/>
+                    </a:ext>
+                  </a:extLst>
+                </a:hlinkClick>
+              </a:rPr>
+              <a:t>・一条工務店「住まいのインテリアに関する意識調査」2022年</a:t>
+            </a:r>
+            <a:endParaRPr lang="en-US" sz="1000" dirty="0"/>
+          </a:p>
+          <a:p>
+            <a:pPr indent="0" marL="0">
+              <a:buNone/>
+            </a:pPr>
+            <a:r>
+              <a:rPr lang="en-US" sz="1000" u="sng" dirty="0">
+                <a:solidFill>
+                  <a:schemeClr val="accent6"/>
+                </a:solidFill>
+                <a:hlinkClick r:id="rId2" invalidUrl="" action="" tgtFrame="" tooltip="" history="1" highlightClick="0" endSnd="0">
+                  <a:extLst>
+                    <a:ext uri="{A12FA001-AC4F-418D-AE19-62706E023703}">
+                      <ahyp:hlinkClr xmlns:ahyp="http://schemas.microsoft.com/office/drawing/2018/hyperlinkcolor" val="tx"/>
+                    </a:ext>
+                  </a:extLst>
+                </a:hlinkClick>
+              </a:rPr>
+              <a:t>・一条工務店「自宅のインテリアに関する意識調査 2024」2024年5月（全国766人）</a:t>
+            </a:r>
+            <a:endParaRPr lang="en-US" sz="1000" dirty="0"/>
+          </a:p>
+          <a:p>
+            <a:pPr indent="0" marL="0">
+              <a:buNone/>
+            </a:pPr>
+            <a:r>
+              <a:rPr lang="en-US" sz="1000" u="sng" dirty="0">
+                <a:solidFill>
+                  <a:schemeClr val="accent6"/>
+                </a:solidFill>
+                <a:hlinkClick r:id="rId3" invalidUrl="" action="" tgtFrame="" tooltip="" history="1" highlightClick="0" endSnd="0">
+                  <a:extLst>
+                    <a:ext uri="{A12FA001-AC4F-418D-AE19-62706E023703}">
+                      <ahyp:hlinkClr xmlns:ahyp="http://schemas.microsoft.com/office/drawing/2018/hyperlinkcolor" val="tx"/>
+                    </a:ext>
+                  </a:extLst>
+                </a:hlinkClick>
+              </a:rPr>
+              <a:t>・一条工務店「自宅のインテリアに関する意識調査 2025」2025年7月発表</a:t>
+            </a:r>
+            <a:endParaRPr lang="en-US" sz="1000" dirty="0"/>
+          </a:p>
+          <a:p>
+            <a:pPr indent="0" marL="0">
+              <a:buNone/>
+            </a:pPr>
+            <a:r>
+              <a:rPr lang="en-US" sz="1000" u="sng" dirty="0">
+                <a:solidFill>
+                  <a:schemeClr val="accent6"/>
+                </a:solidFill>
+                <a:hlinkClick r:id="rId4" invalidUrl="" action="" tgtFrame="" tooltip="" history="1" highlightClick="0" endSnd="0">
+                  <a:extLst>
+                    <a:ext uri="{A12FA001-AC4F-418D-AE19-62706E023703}">
+                      <ahyp:hlinkClr xmlns:ahyp="http://schemas.microsoft.com/office/drawing/2018/hyperlinkcolor" val="tx"/>
+                    </a:ext>
+                  </a:extLst>
+                </a:hlinkClick>
+              </a:rPr>
+              <a:t>・マイボイスコム「インテリアのアンケート調査（10）」2025年6月（11,669人）</a:t>
+            </a:r>
+            <a:endParaRPr lang="en-US" sz="1000" dirty="0"/>
           </a:p>
         </p:txBody>
       </p:sp>
@@ -7804,7 +8019,7 @@
             <a:r>
               <a:rPr lang="en-US" sz="2800" b="1" dirty="0">
                 <a:solidFill>
-                  <a:schemeClr val="bg1"/>
+                  <a:schemeClr val="tx2"/>
                 </a:solidFill>
               </a:rPr>
               <a:t>だから今、ブランドがスタイルを提案する</a:t>
@@ -7830,7 +8045,7 @@
             </a:avLst>
           </a:prstGeom>
           <a:solidFill>
-            <a:srgbClr val="3D4E47"/>
+            <a:schemeClr val="bg1"/>
           </a:solidFill>
           <a:ln/>
         </p:spPr>
@@ -7862,7 +8077,7 @@
             <a:r>
               <a:rPr lang="en-US" sz="1500" b="1" dirty="0">
                 <a:solidFill>
-                  <a:schemeClr val="bg1"/>
+                  <a:schemeClr val="tx2"/>
                 </a:solidFill>
               </a:rPr>
               <a:t>興味はある</a:t>
@@ -7898,7 +8113,7 @@
             <a:r>
               <a:rPr lang="en-US" sz="1200" dirty="0">
                 <a:solidFill>
-                  <a:schemeClr val="accent5"/>
+                  <a:schemeClr val="tx1"/>
                 </a:solidFill>
               </a:rPr>
               <a:t>7割以上が</a:t>
@@ -7912,7 +8127,7 @@
             <a:r>
               <a:rPr lang="en-US" sz="1200" dirty="0">
                 <a:solidFill>
-                  <a:schemeClr val="accent5"/>
+                  <a:schemeClr val="tx1"/>
                 </a:solidFill>
               </a:rPr>
               <a:t>こだわりたい</a:t>
@@ -7936,7 +8151,7 @@
             <a:avLst/>
           </a:prstGeom>
           <a:solidFill>
-            <a:schemeClr val="accent5"/>
+            <a:schemeClr val="accent1"/>
           </a:solidFill>
           <a:ln/>
         </p:spPr>
@@ -7958,7 +8173,7 @@
             </a:avLst>
           </a:prstGeom>
           <a:solidFill>
-            <a:srgbClr val="3D4E47"/>
+            <a:schemeClr val="bg1"/>
           </a:solidFill>
           <a:ln/>
         </p:spPr>
@@ -7990,7 +8205,7 @@
             <a:r>
               <a:rPr lang="en-US" sz="1500" b="1" dirty="0">
                 <a:solidFill>
-                  <a:schemeClr val="bg1"/>
+                  <a:schemeClr val="tx2"/>
                 </a:solidFill>
               </a:rPr>
               <a:t>でも自信がない</a:t>
@@ -8026,7 +8241,7 @@
             <a:r>
               <a:rPr lang="en-US" sz="1200" dirty="0">
                 <a:solidFill>
-                  <a:schemeClr val="accent5"/>
+                  <a:schemeClr val="tx1"/>
                 </a:solidFill>
               </a:rPr>
               <a:t>約6割がセンスに</a:t>
@@ -8040,7 +8255,7 @@
             <a:r>
               <a:rPr lang="en-US" sz="1200" dirty="0">
                 <a:solidFill>
-                  <a:schemeClr val="accent5"/>
+                  <a:schemeClr val="tx1"/>
                 </a:solidFill>
               </a:rPr>
               <a:t>自信なし</a:t>
@@ -8064,7 +8279,7 @@
             <a:avLst/>
           </a:prstGeom>
           <a:solidFill>
-            <a:schemeClr val="accent5"/>
+            <a:schemeClr val="accent1"/>
           </a:solidFill>
           <a:ln/>
         </p:spPr>
@@ -8086,7 +8301,7 @@
             </a:avLst>
           </a:prstGeom>
           <a:solidFill>
-            <a:srgbClr val="3D4E47"/>
+            <a:schemeClr val="bg1"/>
           </a:solidFill>
           <a:ln/>
         </p:spPr>
@@ -8118,7 +8333,7 @@
             <a:r>
               <a:rPr lang="en-US" sz="1500" b="1" dirty="0">
                 <a:solidFill>
-                  <a:schemeClr val="bg1"/>
+                  <a:schemeClr val="tx2"/>
                 </a:solidFill>
               </a:rPr>
               <a:t>無難を選ぶ</a:t>
@@ -8154,7 +8369,7 @@
             <a:r>
               <a:rPr lang="en-US" sz="1200" dirty="0">
                 <a:solidFill>
-                  <a:schemeClr val="accent5"/>
+                  <a:schemeClr val="tx1"/>
                 </a:solidFill>
               </a:rPr>
               <a:t>ナチュラル・</a:t>
@@ -8168,7 +8383,7 @@
             <a:r>
               <a:rPr lang="en-US" sz="1200" dirty="0">
                 <a:solidFill>
-                  <a:schemeClr val="accent5"/>
+                  <a:schemeClr val="tx1"/>
                 </a:solidFill>
               </a:rPr>
               <a:t>シンプルなど</a:t>
@@ -8182,7 +8397,7 @@
             <a:r>
               <a:rPr lang="en-US" sz="1200" dirty="0">
                 <a:solidFill>
-                  <a:schemeClr val="accent5"/>
+                  <a:schemeClr val="tx1"/>
                 </a:solidFill>
               </a:rPr>
               <a:t>ベーシックが上位</a:t>
@@ -8206,7 +8421,7 @@
             <a:avLst/>
           </a:prstGeom>
           <a:solidFill>
-            <a:schemeClr val="accent5"/>
+            <a:schemeClr val="accent1"/>
           </a:solidFill>
           <a:ln/>
         </p:spPr>
@@ -8363,7 +8578,7 @@
             <a:r>
               <a:rPr lang="en-US" sz="1400" dirty="0">
                 <a:solidFill>
-                  <a:schemeClr val="bg1"/>
+                  <a:schemeClr val="tx1"/>
                 </a:solidFill>
               </a:rPr>
               <a:t>ベーシックが人気なのは、「好きだから」だけでなく「無難だから」でもある。</a:t>
@@ -8380,7 +8595,7 @@
             <a:r>
               <a:rPr lang="en-US" sz="1400" dirty="0">
                 <a:solidFill>
-                  <a:schemeClr val="bg1"/>
+                  <a:schemeClr val="tx1"/>
                 </a:solidFill>
               </a:rPr>
               <a:t>まだ多くの人が自分でコーディネートできない今は、ブランドが提案し、一緒に学んでいく時期。</a:t>
@@ -8397,7 +8612,7 @@
             <a:r>
               <a:rPr lang="en-US" sz="1400" b="1" dirty="0">
                 <a:solidFill>
-                  <a:schemeClr val="accent5"/>
+                  <a:schemeClr val="accent2"/>
                 </a:solidFill>
               </a:rPr>
               <a:t>だから私たちが、スタイルを知る必要がある。</a:t>
@@ -8408,7 +8623,43 @@
       </p:sp>
       <p:sp>
         <p:nvSpPr>
-          <p:cNvPr id="19" name="Text 0"/>
+          <p:cNvPr id="19" name="sources"/>
+          <p:cNvSpPr txBox="1"/>
+          <p:nvPr/>
+        </p:nvSpPr>
+        <p:spPr>
+          <a:xfrm>
+            <a:off x="640080" y="4572000"/>
+            <a:ext cx="7863840" cy="274320"/>
+          </a:xfrm>
+          <a:prstGeom prst="rect">
+            <a:avLst/>
+          </a:prstGeom>
+          <a:noFill/>
+          <a:ln/>
+        </p:spPr>
+        <p:txBody>
+          <a:bodyPr wrap="square" lIns="0" tIns="0" rIns="0" bIns="0" rtlCol="0" anchor="ctr"/>
+          <a:lstStyle/>
+          <a:p>
+            <a:pPr indent="0" marL="0">
+              <a:buNone/>
+            </a:pPr>
+            <a:r>
+              <a:rPr lang="en-US" sz="900" dirty="0">
+                <a:solidFill>
+                  <a:schemeClr val="accent6"/>
+                </a:solidFill>
+              </a:rPr>
+              <a:t>出典：一条工務店 インテリア意識調査（2022・2024・2025年）、マイボイスコム（2025年）　※「無難だから」はデータからの解釈</a:t>
+            </a:r>
+            <a:endParaRPr lang="en-US" sz="900" dirty="0"/>
+          </a:p>
+        </p:txBody>
+      </p:sp>
+      <p:sp>
+        <p:nvSpPr>
+          <p:cNvPr id="20" name="Text 0"/>
           <p:cNvSpPr/>
           <p:nvPr>
             <p:ph idx="100" type="title" hasCustomPrompt="1"/>
@@ -8438,7 +8689,7 @@
       </p:sp>
       <p:sp>
         <p:nvSpPr>
-          <p:cNvPr id="20" name="Text 0"/>
+          <p:cNvPr id="21" name="Text 0"/>
           <p:cNvSpPr/>
           <p:nvPr>
             <p:ph idx="101" type="body" hasCustomPrompt="1"/>

</xml_diff>

<commit_message>
Add 'where is Nordic style' map slide with reference style positions
Co-Authored-By: Claude Opus 5.5 <noreply@anthropic.com>
Claude-Session: https://claude.ai/code/session_01BHN99WkTUDUfg94JgFGXiz
</commit_message>
<xml_diff>
--- a/workshop1_interior_style.pptx
+++ b/workshop1_interior_style.pptx
@@ -20,9 +20,10 @@
     <p:sldId id="268" r:id="rId14"/>
     <p:sldId id="269" r:id="rId15"/>
     <p:sldId id="270" r:id="rId16"/>
+    <p:sldId id="271" r:id="rId17"/>
   </p:sldIdLst>
   <p:notesMasterIdLst>
-    <p:notesMasterId r:id="rId17"/>
+    <p:notesMasterId r:id="rId18"/>
   </p:notesMasterIdLst>
   <p:sldSz cx="9144000" cy="5143500"/>
   <p:notesSz cx="5143500" cy="9144000"/>
@@ -121,7 +122,7 @@
   <p:extLst>
     <p:ext uri="{521415D9-36F7-43E2-AB2F-B90AF26B5E84}">
       <p14:sectionLst xmlns:p14="http://schemas.microsoft.com/office/powerpoint/2010/main">
-        <p14:section name="導入" id="{a715fe0f-6d07-fb99-a6b2-a62e00c0adc2}">
+        <p14:section name="導入" id="{2171b63a-f2b6-5b13-dd1d-68c361817b27}">
           <p14:sldIdLst>
             <p14:sldId id="256"/>
             <p14:sldId id="257"/>
@@ -130,38 +131,39 @@
             <p14:sldId id="260"/>
           </p14:sldIdLst>
         </p14:section>
-        <p14:section name="① オープニング" id="{b2fb76ef-2485-3ecd-d29d-7c971fa85012}">
+        <p14:section name="① オープニング" id="{6d82a281-f612-8efa-2877-2bc8a8ac5f2e}">
           <p14:sldIdLst>
             <p14:sldId id="261"/>
           </p14:sldIdLst>
         </p14:section>
-        <p14:section name="② デザインの歴史" id="{32c0597f-edad-785a-7363-ae2371ceb3df}">
+        <p14:section name="② デザインの歴史" id="{c45ebc28-0676-0f47-9cb4-5e1a1c94180f}">
           <p14:sldIdLst>
             <p14:sldId id="262"/>
             <p14:sldId id="263"/>
             <p14:sldId id="264"/>
           </p14:sldIdLst>
         </p14:section>
-        <p14:section name="③ スタイルの特徴" id="{9bdb4e47-927b-b7f1-46d6-d2716035de21}">
+        <p14:section name="③ スタイルの特徴" id="{6f74b394-3870-5b66-aaf6-ea88e69bd018}">
           <p14:sldIdLst>
             <p14:sldId id="265"/>
             <p14:sldId id="266"/>
-          </p14:sldIdLst>
-        </p14:section>
-        <p14:section name="④ 北欧スタイルの定義" id="{48338da0-c243-ab5a-0760-a6d34fbff339}">
-          <p14:sldIdLst>
             <p14:sldId id="267"/>
           </p14:sldIdLst>
         </p14:section>
-        <p14:section name="⑤ マトリックス" id="{057c0f8c-7037-f526-20c8-4fd16424fd83}">
+        <p14:section name="④ 北欧スタイルの定義" id="{ada9015e-8c7b-338c-6a86-8caf2334c3a0}">
           <p14:sldIdLst>
             <p14:sldId id="268"/>
-            <p14:sldId id="269"/>
           </p14:sldIdLst>
         </p14:section>
-        <p14:section name="⑥ まとめ" id="{f55e73dc-baa3-93c9-1bc2-5c8f4fb5fb01}">
+        <p14:section name="⑤ マトリックス" id="{138483bf-77ba-8256-537e-3fa03ed7b0cc}">
           <p14:sldIdLst>
+            <p14:sldId id="269"/>
             <p14:sldId id="270"/>
+          </p14:sldIdLst>
+        </p14:section>
+        <p14:section name="⑥ まとめ" id="{85aeaa80-e1de-d593-2c4c-7e94aac9e497}">
+          <p14:sldIdLst>
+            <p14:sldId id="271"/>
           </p14:sldIdLst>
         </p14:section>
       </p14:sectionLst>
@@ -832,7 +834,7 @@
           <a:p>
             <a:r>
               <a:rPr lang="en-US" dirty="0"/>
-              <a:t/>
+              <a:t>問いかけ：「みんなの思う北欧はどこ？」付箋を置いてもらってから、北欧モダンと北欧ビンテージの位置を見せる。</a:t>
             </a:r>
             <a:endParaRPr lang="en-US" dirty="0"/>
           </a:p>
@@ -1120,6 +1122,94 @@
             <a:fld id="{F7021451-1387-4CA6-816F-3879F97B5CBC}" type="slidenum">
               <a:rPr lang="en-US"/>
               <a:t>15</a:t>
+            </a:fld>
+            <a:endParaRPr lang="en-US"/>
+          </a:p>
+        </p:txBody>
+      </p:sp>
+    </p:spTree>
+    <p:extLst>
+      <p:ext uri="{BB962C8B-B14F-4D97-AF65-F5344CB8AC3E}">
+        <p14:creationId xmlns:p14="http://schemas.microsoft.com/office/powerpoint/2010/main" val="1024086991"/>
+      </p:ext>
+    </p:extLst>
+  </p:cSld>
+  <p:clrMapOvr>
+    <a:masterClrMapping/>
+  </p:clrMapOvr>
+</p:notes>
+</file>
+
+<file path=ppt/notesSlides/notesSlide16.xml><?xml version="1.0" encoding="utf-8"?>
+<p:notes xmlns:a="http://schemas.openxmlformats.org/drawingml/2006/main" xmlns:r="http://schemas.openxmlformats.org/officeDocument/2006/relationships" xmlns:p="http://schemas.openxmlformats.org/presentationml/2006/main">
+  <p:cSld>
+    <p:spTree>
+      <p:nvGrpSpPr>
+        <p:cNvPr id="1" name=""/>
+        <p:cNvGrpSpPr/>
+        <p:nvPr/>
+      </p:nvGrpSpPr>
+      <p:grpSpPr>
+        <a:xfrm>
+          <a:off x="0" y="0"/>
+          <a:ext cx="0" cy="0"/>
+          <a:chOff x="0" y="0"/>
+          <a:chExt cx="0" cy="0"/>
+        </a:xfrm>
+      </p:grpSpPr>
+      <p:sp>
+        <p:nvSpPr>
+          <p:cNvPr id="2" name="Slide Image Placeholder 1"/>
+          <p:cNvSpPr>
+            <a:spLocks noGrp="1" noRot="1" noChangeAspect="1"/>
+          </p:cNvSpPr>
+          <p:nvPr>
+            <p:ph type="sldImg"/>
+          </p:nvPr>
+        </p:nvSpPr>
+        <p:spPr/>
+      </p:sp>
+      <p:sp>
+        <p:nvSpPr>
+          <p:cNvPr id="3" name="Notes Placeholder 2"/>
+          <p:cNvSpPr>
+            <a:spLocks noGrp="1"/>
+          </p:cNvSpPr>
+          <p:nvPr>
+            <p:ph type="body" idx="1"/>
+          </p:nvPr>
+        </p:nvSpPr>
+        <p:spPr/>
+        <p:txBody>
+          <a:bodyPr/>
+          <a:lstStyle/>
+          <a:p>
+            <a:r>
+              <a:rPr lang="en-US" dirty="0"/>
+              <a:t/>
+            </a:r>
+            <a:endParaRPr lang="en-US" dirty="0"/>
+          </a:p>
+        </p:txBody>
+      </p:sp>
+      <p:sp>
+        <p:nvSpPr>
+          <p:cNvPr id="4" name="Slide Number Placeholder 3"/>
+          <p:cNvSpPr>
+            <a:spLocks noGrp="1"/>
+          </p:cNvSpPr>
+          <p:nvPr>
+            <p:ph type="sldNum" sz="quarter" idx="10"/>
+          </p:nvPr>
+        </p:nvSpPr>
+        <p:spPr/>
+        <p:txBody>
+          <a:bodyPr/>
+          <a:lstStyle/>
+          <a:p>
+            <a:fld id="{F7021451-1387-4CA6-816F-3879F97B5CBC}" type="slidenum">
+              <a:rPr lang="en-US"/>
+              <a:t>16</a:t>
             </a:fld>
             <a:endParaRPr lang="en-US"/>
           </a:p>
@@ -3915,7 +4005,7 @@
                   <a:schemeClr val="accent1"/>
                 </a:solidFill>
               </a:rPr>
-              <a:t>④ グループワーク　15分</a:t>
+              <a:t>③ スタイルの特徴</a:t>
             </a:r>
             <a:endParaRPr lang="en-US" sz="1100" dirty="0"/>
           </a:p>
@@ -3953,6 +4043,904 @@
                   <a:schemeClr val="tx2"/>
                 </a:solidFill>
               </a:rPr>
+              <a:t>北欧スタイルはどこ？</a:t>
+            </a:r>
+            <a:endParaRPr lang="en-US" sz="2600" dirty="0"/>
+          </a:p>
+        </p:txBody>
+      </p:sp>
+      <p:sp>
+        <p:nvSpPr>
+          <p:cNvPr id="4" name="map-bg"/>
+          <p:cNvSpPr/>
+          <p:nvPr/>
+        </p:nvSpPr>
+        <p:spPr>
+          <a:xfrm>
+            <a:off x="1097280" y="1051560"/>
+            <a:ext cx="6949440" cy="3566160"/>
+          </a:xfrm>
+          <a:prstGeom prst="rect">
+            <a:avLst/>
+          </a:prstGeom>
+          <a:solidFill>
+            <a:schemeClr val="bg2"/>
+          </a:solidFill>
+          <a:ln/>
+        </p:spPr>
+      </p:sp>
+      <p:sp>
+        <p:nvSpPr>
+          <p:cNvPr id="5" name="Shape 3"/>
+          <p:cNvSpPr/>
+          <p:nvPr/>
+        </p:nvSpPr>
+        <p:spPr>
+          <a:xfrm>
+            <a:off x="1097280" y="2834640"/>
+            <a:ext cx="6949440" cy="0"/>
+          </a:xfrm>
+          <a:prstGeom prst="line">
+            <a:avLst/>
+          </a:prstGeom>
+          <a:noFill/>
+          <a:ln w="19050">
+            <a:solidFill>
+              <a:schemeClr val="accent6"/>
+            </a:solidFill>
+            <a:prstDash val="solid"/>
+            <a:headEnd type="triangle"/>
+            <a:tailEnd type="triangle"/>
+          </a:ln>
+        </p:spPr>
+      </p:sp>
+      <p:sp>
+        <p:nvSpPr>
+          <p:cNvPr id="6" name="Shape 4"/>
+          <p:cNvSpPr/>
+          <p:nvPr/>
+        </p:nvSpPr>
+        <p:spPr>
+          <a:xfrm>
+            <a:off x="4572000" y="1051560"/>
+            <a:ext cx="0" cy="3566160"/>
+          </a:xfrm>
+          <a:prstGeom prst="line">
+            <a:avLst/>
+          </a:prstGeom>
+          <a:noFill/>
+          <a:ln w="19050">
+            <a:solidFill>
+              <a:schemeClr val="accent6"/>
+            </a:solidFill>
+            <a:prstDash val="solid"/>
+            <a:headEnd type="triangle"/>
+            <a:tailEnd type="triangle"/>
+          </a:ln>
+        </p:spPr>
+      </p:sp>
+      <p:sp>
+        <p:nvSpPr>
+          <p:cNvPr id="7" name="Text 5"/>
+          <p:cNvSpPr txBox="1"/>
+          <p:nvPr/>
+        </p:nvSpPr>
+        <p:spPr>
+          <a:xfrm>
+            <a:off x="1188720" y="2907792"/>
+            <a:ext cx="1828800" cy="274320"/>
+          </a:xfrm>
+          <a:prstGeom prst="rect">
+            <a:avLst/>
+          </a:prstGeom>
+          <a:noFill/>
+          <a:ln/>
+        </p:spPr>
+        <p:txBody>
+          <a:bodyPr wrap="square" lIns="0" tIns="0" rIns="0" bIns="0" rtlCol="0" anchor="ctr"/>
+          <a:lstStyle/>
+          <a:p>
+            <a:pPr algn="l" indent="0" marL="0">
+              <a:buNone/>
+            </a:pPr>
+            <a:r>
+              <a:rPr lang="en-US" sz="1200" b="1" dirty="0">
+                <a:solidFill>
+                  <a:schemeClr val="accent2"/>
+                </a:solidFill>
+              </a:rPr>
+              <a:t>トラディショナル</a:t>
+            </a:r>
+            <a:endParaRPr lang="en-US" sz="1200" dirty="0"/>
+          </a:p>
+        </p:txBody>
+      </p:sp>
+      <p:sp>
+        <p:nvSpPr>
+          <p:cNvPr id="8" name="Text 6"/>
+          <p:cNvSpPr txBox="1"/>
+          <p:nvPr/>
+        </p:nvSpPr>
+        <p:spPr>
+          <a:xfrm>
+            <a:off x="6126480" y="2907792"/>
+            <a:ext cx="1828800" cy="274320"/>
+          </a:xfrm>
+          <a:prstGeom prst="rect">
+            <a:avLst/>
+          </a:prstGeom>
+          <a:noFill/>
+          <a:ln/>
+        </p:spPr>
+        <p:txBody>
+          <a:bodyPr wrap="square" lIns="0" tIns="0" rIns="0" bIns="0" rtlCol="0" anchor="ctr"/>
+          <a:lstStyle/>
+          <a:p>
+            <a:pPr algn="r" indent="0" marL="0">
+              <a:buNone/>
+            </a:pPr>
+            <a:r>
+              <a:rPr lang="en-US" sz="1200" b="1" dirty="0">
+                <a:solidFill>
+                  <a:schemeClr val="tx2"/>
+                </a:solidFill>
+              </a:rPr>
+              <a:t>モダン</a:t>
+            </a:r>
+            <a:endParaRPr lang="en-US" sz="1200" dirty="0"/>
+          </a:p>
+        </p:txBody>
+      </p:sp>
+      <p:sp>
+        <p:nvSpPr>
+          <p:cNvPr id="9" name="Text 7"/>
+          <p:cNvSpPr txBox="1"/>
+          <p:nvPr/>
+        </p:nvSpPr>
+        <p:spPr>
+          <a:xfrm>
+            <a:off x="4663440" y="1124712"/>
+            <a:ext cx="2743200" cy="274320"/>
+          </a:xfrm>
+          <a:prstGeom prst="rect">
+            <a:avLst/>
+          </a:prstGeom>
+          <a:noFill/>
+          <a:ln/>
+        </p:spPr>
+        <p:txBody>
+          <a:bodyPr wrap="square" lIns="0" tIns="0" rIns="0" bIns="0" rtlCol="0" anchor="ctr"/>
+          <a:lstStyle/>
+          <a:p>
+            <a:pPr algn="l" indent="0" marL="0">
+              <a:buNone/>
+            </a:pPr>
+            <a:r>
+              <a:rPr lang="en-US" sz="1200" b="1" dirty="0">
+                <a:solidFill>
+                  <a:schemeClr val="tx2"/>
+                </a:solidFill>
+              </a:rPr>
+              <a:t>軽い（淡い色・細い脚）</a:t>
+            </a:r>
+            <a:endParaRPr lang="en-US" sz="1200" dirty="0"/>
+          </a:p>
+        </p:txBody>
+      </p:sp>
+      <p:sp>
+        <p:nvSpPr>
+          <p:cNvPr id="10" name="Text 8"/>
+          <p:cNvSpPr txBox="1"/>
+          <p:nvPr/>
+        </p:nvSpPr>
+        <p:spPr>
+          <a:xfrm>
+            <a:off x="4663440" y="4270248"/>
+            <a:ext cx="2743200" cy="274320"/>
+          </a:xfrm>
+          <a:prstGeom prst="rect">
+            <a:avLst/>
+          </a:prstGeom>
+          <a:noFill/>
+          <a:ln/>
+        </p:spPr>
+        <p:txBody>
+          <a:bodyPr wrap="square" lIns="0" tIns="0" rIns="0" bIns="0" rtlCol="0" anchor="ctr"/>
+          <a:lstStyle/>
+          <a:p>
+            <a:pPr algn="l" indent="0" marL="0">
+              <a:buNone/>
+            </a:pPr>
+            <a:r>
+              <a:rPr lang="en-US" sz="1200" b="1" dirty="0">
+                <a:solidFill>
+                  <a:schemeClr val="tx2"/>
+                </a:solidFill>
+              </a:rPr>
+              <a:t>重い（濃い色・量感・装飾）</a:t>
+            </a:r>
+            <a:endParaRPr lang="en-US" sz="1200" dirty="0"/>
+          </a:p>
+        </p:txBody>
+      </p:sp>
+      <p:sp>
+        <p:nvSpPr>
+          <p:cNvPr id="11" name="style-dot-0"/>
+          <p:cNvSpPr/>
+          <p:nvPr/>
+        </p:nvSpPr>
+        <p:spPr>
+          <a:xfrm>
+            <a:off x="6135624" y="1719072"/>
+            <a:ext cx="219456" cy="219456"/>
+          </a:xfrm>
+          <a:prstGeom prst="ellipse">
+            <a:avLst/>
+          </a:prstGeom>
+          <a:solidFill>
+            <a:schemeClr val="accent2"/>
+          </a:solidFill>
+          <a:ln/>
+        </p:spPr>
+      </p:sp>
+      <p:sp>
+        <p:nvSpPr>
+          <p:cNvPr id="12" name="style-label-0"/>
+          <p:cNvSpPr txBox="1"/>
+          <p:nvPr/>
+        </p:nvSpPr>
+        <p:spPr>
+          <a:xfrm>
+            <a:off x="6409944" y="1600200"/>
+            <a:ext cx="1234440" cy="457200"/>
+          </a:xfrm>
+          <a:prstGeom prst="rect">
+            <a:avLst/>
+          </a:prstGeom>
+          <a:noFill/>
+          <a:ln/>
+        </p:spPr>
+        <p:txBody>
+          <a:bodyPr wrap="square" lIns="0" tIns="0" rIns="0" bIns="0" rtlCol="0" anchor="ctr"/>
+          <a:lstStyle/>
+          <a:p>
+            <a:pPr algn="l" indent="0" marL="0">
+              <a:buNone/>
+            </a:pPr>
+            <a:r>
+              <a:rPr lang="en-US" sz="1100" b="1" dirty="0">
+                <a:solidFill>
+                  <a:schemeClr val="accent2"/>
+                </a:solidFill>
+              </a:rPr>
+              <a:t>北欧モダン</a:t>
+            </a:r>
+            <a:endParaRPr lang="en-US" sz="1100" dirty="0"/>
+          </a:p>
+        </p:txBody>
+      </p:sp>
+      <p:sp>
+        <p:nvSpPr>
+          <p:cNvPr id="13" name="style-dot-1"/>
+          <p:cNvSpPr/>
+          <p:nvPr/>
+        </p:nvSpPr>
+        <p:spPr>
+          <a:xfrm>
+            <a:off x="6976872" y="2221992"/>
+            <a:ext cx="219456" cy="219456"/>
+          </a:xfrm>
+          <a:prstGeom prst="ellipse">
+            <a:avLst/>
+          </a:prstGeom>
+          <a:solidFill>
+            <a:schemeClr val="accent6"/>
+          </a:solidFill>
+          <a:ln/>
+        </p:spPr>
+      </p:sp>
+      <p:sp>
+        <p:nvSpPr>
+          <p:cNvPr id="14" name="style-label-1"/>
+          <p:cNvSpPr txBox="1"/>
+          <p:nvPr/>
+        </p:nvSpPr>
+        <p:spPr>
+          <a:xfrm>
+            <a:off x="7251192" y="2103120"/>
+            <a:ext cx="1234440" cy="457200"/>
+          </a:xfrm>
+          <a:prstGeom prst="rect">
+            <a:avLst/>
+          </a:prstGeom>
+          <a:noFill/>
+          <a:ln/>
+        </p:spPr>
+        <p:txBody>
+          <a:bodyPr wrap="square" lIns="0" tIns="0" rIns="0" bIns="0" rtlCol="0" anchor="ctr"/>
+          <a:lstStyle/>
+          <a:p>
+            <a:pPr algn="l" indent="0" marL="0">
+              <a:buNone/>
+            </a:pPr>
+            <a:r>
+              <a:rPr lang="en-US" sz="1100" dirty="0">
+                <a:solidFill>
+                  <a:schemeClr val="tx1"/>
+                </a:solidFill>
+              </a:rPr>
+              <a:t>シンプル</a:t>
+            </a:r>
+            <a:endParaRPr lang="en-US" sz="1100" dirty="0"/>
+          </a:p>
+          <a:p>
+            <a:pPr algn="l" indent="0" marL="0">
+              <a:buNone/>
+            </a:pPr>
+            <a:r>
+              <a:rPr lang="en-US" sz="1100" dirty="0">
+                <a:solidFill>
+                  <a:schemeClr val="tx1"/>
+                </a:solidFill>
+              </a:rPr>
+              <a:t>モダン</a:t>
+            </a:r>
+            <a:endParaRPr lang="en-US" sz="1100" dirty="0"/>
+          </a:p>
+        </p:txBody>
+      </p:sp>
+      <p:sp>
+        <p:nvSpPr>
+          <p:cNvPr id="15" name="style-dot-2"/>
+          <p:cNvSpPr/>
+          <p:nvPr/>
+        </p:nvSpPr>
+        <p:spPr>
+          <a:xfrm>
+            <a:off x="5513832" y="2404872"/>
+            <a:ext cx="219456" cy="219456"/>
+          </a:xfrm>
+          <a:prstGeom prst="ellipse">
+            <a:avLst/>
+          </a:prstGeom>
+          <a:solidFill>
+            <a:schemeClr val="accent6"/>
+          </a:solidFill>
+          <a:ln/>
+        </p:spPr>
+      </p:sp>
+      <p:sp>
+        <p:nvSpPr>
+          <p:cNvPr id="16" name="style-label-2"/>
+          <p:cNvSpPr txBox="1"/>
+          <p:nvPr/>
+        </p:nvSpPr>
+        <p:spPr>
+          <a:xfrm>
+            <a:off x="5788152" y="2286000"/>
+            <a:ext cx="1234440" cy="457200"/>
+          </a:xfrm>
+          <a:prstGeom prst="rect">
+            <a:avLst/>
+          </a:prstGeom>
+          <a:noFill/>
+          <a:ln/>
+        </p:spPr>
+        <p:txBody>
+          <a:bodyPr wrap="square" lIns="0" tIns="0" rIns="0" bIns="0" rtlCol="0" anchor="ctr"/>
+          <a:lstStyle/>
+          <a:p>
+            <a:pPr algn="l" indent="0" marL="0">
+              <a:buNone/>
+            </a:pPr>
+            <a:r>
+              <a:rPr lang="en-US" sz="1100" dirty="0">
+                <a:solidFill>
+                  <a:schemeClr val="tx1"/>
+                </a:solidFill>
+              </a:rPr>
+              <a:t>マンハッタン</a:t>
+            </a:r>
+            <a:endParaRPr lang="en-US" sz="1100" dirty="0"/>
+          </a:p>
+          <a:p>
+            <a:pPr algn="l" indent="0" marL="0">
+              <a:buNone/>
+            </a:pPr>
+            <a:r>
+              <a:rPr lang="en-US" sz="1100" dirty="0">
+                <a:solidFill>
+                  <a:schemeClr val="tx1"/>
+                </a:solidFill>
+              </a:rPr>
+              <a:t>モダン</a:t>
+            </a:r>
+            <a:endParaRPr lang="en-US" sz="1100" dirty="0"/>
+          </a:p>
+        </p:txBody>
+      </p:sp>
+      <p:sp>
+        <p:nvSpPr>
+          <p:cNvPr id="17" name="style-dot-3"/>
+          <p:cNvSpPr/>
+          <p:nvPr/>
+        </p:nvSpPr>
+        <p:spPr>
+          <a:xfrm>
+            <a:off x="3419856" y="2560320"/>
+            <a:ext cx="219456" cy="219456"/>
+          </a:xfrm>
+          <a:prstGeom prst="ellipse">
+            <a:avLst/>
+          </a:prstGeom>
+          <a:solidFill>
+            <a:schemeClr val="accent6"/>
+          </a:solidFill>
+          <a:ln/>
+        </p:spPr>
+      </p:sp>
+      <p:sp>
+        <p:nvSpPr>
+          <p:cNvPr id="18" name="style-label-3"/>
+          <p:cNvSpPr txBox="1"/>
+          <p:nvPr/>
+        </p:nvSpPr>
+        <p:spPr>
+          <a:xfrm>
+            <a:off x="2130552" y="2441448"/>
+            <a:ext cx="1234440" cy="457200"/>
+          </a:xfrm>
+          <a:prstGeom prst="rect">
+            <a:avLst/>
+          </a:prstGeom>
+          <a:noFill/>
+          <a:ln/>
+        </p:spPr>
+        <p:txBody>
+          <a:bodyPr wrap="square" lIns="0" tIns="0" rIns="0" bIns="0" rtlCol="0" anchor="ctr"/>
+          <a:lstStyle/>
+          <a:p>
+            <a:pPr algn="r" indent="0" marL="0">
+              <a:buNone/>
+            </a:pPr>
+            <a:r>
+              <a:rPr lang="en-US" sz="1100" dirty="0">
+                <a:solidFill>
+                  <a:schemeClr val="tx1"/>
+                </a:solidFill>
+              </a:rPr>
+              <a:t>シーサイド</a:t>
+            </a:r>
+            <a:endParaRPr lang="en-US" sz="1100" dirty="0"/>
+          </a:p>
+        </p:txBody>
+      </p:sp>
+      <p:sp>
+        <p:nvSpPr>
+          <p:cNvPr id="19" name="style-dot-4"/>
+          <p:cNvSpPr/>
+          <p:nvPr/>
+        </p:nvSpPr>
+        <p:spPr>
+          <a:xfrm>
+            <a:off x="4032504" y="2980944"/>
+            <a:ext cx="219456" cy="219456"/>
+          </a:xfrm>
+          <a:prstGeom prst="ellipse">
+            <a:avLst/>
+          </a:prstGeom>
+          <a:solidFill>
+            <a:schemeClr val="accent6"/>
+          </a:solidFill>
+          <a:ln/>
+        </p:spPr>
+      </p:sp>
+      <p:sp>
+        <p:nvSpPr>
+          <p:cNvPr id="20" name="style-label-4"/>
+          <p:cNvSpPr txBox="1"/>
+          <p:nvPr/>
+        </p:nvSpPr>
+        <p:spPr>
+          <a:xfrm>
+            <a:off x="2743200" y="2862072"/>
+            <a:ext cx="1234440" cy="457200"/>
+          </a:xfrm>
+          <a:prstGeom prst="rect">
+            <a:avLst/>
+          </a:prstGeom>
+          <a:noFill/>
+          <a:ln/>
+        </p:spPr>
+        <p:txBody>
+          <a:bodyPr wrap="square" lIns="0" tIns="0" rIns="0" bIns="0" rtlCol="0" anchor="ctr"/>
+          <a:lstStyle/>
+          <a:p>
+            <a:pPr algn="r" indent="0" marL="0">
+              <a:buNone/>
+            </a:pPr>
+            <a:r>
+              <a:rPr lang="en-US" sz="1100" dirty="0">
+                <a:solidFill>
+                  <a:schemeClr val="tx1"/>
+                </a:solidFill>
+              </a:rPr>
+              <a:t>BOHO</a:t>
+            </a:r>
+            <a:endParaRPr lang="en-US" sz="1100" dirty="0"/>
+          </a:p>
+        </p:txBody>
+      </p:sp>
+      <p:sp>
+        <p:nvSpPr>
+          <p:cNvPr id="21" name="style-dot-5"/>
+          <p:cNvSpPr/>
+          <p:nvPr/>
+        </p:nvSpPr>
+        <p:spPr>
+          <a:xfrm>
+            <a:off x="5742432" y="3273552"/>
+            <a:ext cx="219456" cy="219456"/>
+          </a:xfrm>
+          <a:prstGeom prst="ellipse">
+            <a:avLst/>
+          </a:prstGeom>
+          <a:solidFill>
+            <a:schemeClr val="accent6"/>
+          </a:solidFill>
+          <a:ln/>
+        </p:spPr>
+      </p:sp>
+      <p:sp>
+        <p:nvSpPr>
+          <p:cNvPr id="22" name="style-label-5"/>
+          <p:cNvSpPr txBox="1"/>
+          <p:nvPr/>
+        </p:nvSpPr>
+        <p:spPr>
+          <a:xfrm>
+            <a:off x="6016752" y="3154680"/>
+            <a:ext cx="1234440" cy="457200"/>
+          </a:xfrm>
+          <a:prstGeom prst="rect">
+            <a:avLst/>
+          </a:prstGeom>
+          <a:noFill/>
+          <a:ln/>
+        </p:spPr>
+        <p:txBody>
+          <a:bodyPr wrap="square" lIns="0" tIns="0" rIns="0" bIns="0" rtlCol="0" anchor="ctr"/>
+          <a:lstStyle/>
+          <a:p>
+            <a:pPr algn="l" indent="0" marL="0">
+              <a:buNone/>
+            </a:pPr>
+            <a:r>
+              <a:rPr lang="en-US" sz="1100" dirty="0">
+                <a:solidFill>
+                  <a:schemeClr val="tx1"/>
+                </a:solidFill>
+              </a:rPr>
+              <a:t>ジャパニーズ</a:t>
+            </a:r>
+            <a:endParaRPr lang="en-US" sz="1100" dirty="0"/>
+          </a:p>
+          <a:p>
+            <a:pPr algn="l" indent="0" marL="0">
+              <a:buNone/>
+            </a:pPr>
+            <a:r>
+              <a:rPr lang="en-US" sz="1100" dirty="0">
+                <a:solidFill>
+                  <a:schemeClr val="tx1"/>
+                </a:solidFill>
+              </a:rPr>
+              <a:t>モダン</a:t>
+            </a:r>
+            <a:endParaRPr lang="en-US" sz="1100" dirty="0"/>
+          </a:p>
+        </p:txBody>
+      </p:sp>
+      <p:sp>
+        <p:nvSpPr>
+          <p:cNvPr id="23" name="style-dot-6"/>
+          <p:cNvSpPr/>
+          <p:nvPr/>
+        </p:nvSpPr>
+        <p:spPr>
+          <a:xfrm>
+            <a:off x="4288536" y="3685032"/>
+            <a:ext cx="219456" cy="219456"/>
+          </a:xfrm>
+          <a:prstGeom prst="ellipse">
+            <a:avLst/>
+          </a:prstGeom>
+          <a:solidFill>
+            <a:schemeClr val="accent6"/>
+          </a:solidFill>
+          <a:ln/>
+        </p:spPr>
+      </p:sp>
+      <p:sp>
+        <p:nvSpPr>
+          <p:cNvPr id="24" name="style-label-6"/>
+          <p:cNvSpPr txBox="1"/>
+          <p:nvPr/>
+        </p:nvSpPr>
+        <p:spPr>
+          <a:xfrm>
+            <a:off x="2999232" y="3566160"/>
+            <a:ext cx="1234440" cy="457200"/>
+          </a:xfrm>
+          <a:prstGeom prst="rect">
+            <a:avLst/>
+          </a:prstGeom>
+          <a:noFill/>
+          <a:ln/>
+        </p:spPr>
+        <p:txBody>
+          <a:bodyPr wrap="square" lIns="0" tIns="0" rIns="0" bIns="0" rtlCol="0" anchor="ctr"/>
+          <a:lstStyle/>
+          <a:p>
+            <a:pPr algn="r" indent="0" marL="0">
+              <a:buNone/>
+            </a:pPr>
+            <a:r>
+              <a:rPr lang="en-US" sz="1100" dirty="0">
+                <a:solidFill>
+                  <a:schemeClr val="tx1"/>
+                </a:solidFill>
+              </a:rPr>
+              <a:t>インダストリアル</a:t>
+            </a:r>
+            <a:endParaRPr lang="en-US" sz="1100" dirty="0"/>
+          </a:p>
+        </p:txBody>
+      </p:sp>
+      <p:sp>
+        <p:nvSpPr>
+          <p:cNvPr id="25" name="style-dot-7"/>
+          <p:cNvSpPr/>
+          <p:nvPr/>
+        </p:nvSpPr>
+        <p:spPr>
+          <a:xfrm>
+            <a:off x="4663440" y="3941064"/>
+            <a:ext cx="219456" cy="219456"/>
+          </a:xfrm>
+          <a:prstGeom prst="ellipse">
+            <a:avLst/>
+          </a:prstGeom>
+          <a:solidFill>
+            <a:schemeClr val="accent2"/>
+          </a:solidFill>
+          <a:ln/>
+        </p:spPr>
+      </p:sp>
+      <p:sp>
+        <p:nvSpPr>
+          <p:cNvPr id="26" name="style-label-7"/>
+          <p:cNvSpPr txBox="1"/>
+          <p:nvPr/>
+        </p:nvSpPr>
+        <p:spPr>
+          <a:xfrm>
+            <a:off x="4937760" y="3822192"/>
+            <a:ext cx="1234440" cy="457200"/>
+          </a:xfrm>
+          <a:prstGeom prst="rect">
+            <a:avLst/>
+          </a:prstGeom>
+          <a:noFill/>
+          <a:ln/>
+        </p:spPr>
+        <p:txBody>
+          <a:bodyPr wrap="square" lIns="0" tIns="0" rIns="0" bIns="0" rtlCol="0" anchor="ctr"/>
+          <a:lstStyle/>
+          <a:p>
+            <a:pPr algn="l" indent="0" marL="0">
+              <a:buNone/>
+            </a:pPr>
+            <a:r>
+              <a:rPr lang="en-US" sz="1100" b="1" dirty="0">
+                <a:solidFill>
+                  <a:schemeClr val="accent2"/>
+                </a:solidFill>
+              </a:rPr>
+              <a:t>北欧ビンテージ</a:t>
+            </a:r>
+            <a:endParaRPr lang="en-US" sz="1100" dirty="0"/>
+          </a:p>
+        </p:txBody>
+      </p:sp>
+      <p:sp>
+        <p:nvSpPr>
+          <p:cNvPr id="27" name="nordic-note"/>
+          <p:cNvSpPr txBox="1"/>
+          <p:nvPr/>
+        </p:nvSpPr>
+        <p:spPr>
+          <a:xfrm>
+            <a:off x="1234440" y="3931920"/>
+            <a:ext cx="3108960" cy="548640"/>
+          </a:xfrm>
+          <a:prstGeom prst="rect">
+            <a:avLst/>
+          </a:prstGeom>
+          <a:noFill/>
+          <a:ln/>
+        </p:spPr>
+        <p:txBody>
+          <a:bodyPr wrap="square" lIns="0" tIns="0" rIns="0" bIns="0" rtlCol="0" anchor="b"/>
+          <a:lstStyle/>
+          <a:p>
+            <a:pPr indent="0" marL="0">
+              <a:buNone/>
+            </a:pPr>
+            <a:r>
+              <a:rPr lang="en-US" sz="1100" b="1" dirty="0">
+                <a:solidFill>
+                  <a:schemeClr val="accent2"/>
+                </a:solidFill>
+              </a:rPr>
+              <a:t>同じ「北欧」でも、</a:t>
+            </a:r>
+            <a:endParaRPr lang="en-US" sz="1100" dirty="0"/>
+          </a:p>
+          <a:p>
+            <a:pPr indent="0" marL="0">
+              <a:buNone/>
+            </a:pPr>
+            <a:r>
+              <a:rPr lang="en-US" sz="1100" b="1" dirty="0">
+                <a:solidFill>
+                  <a:schemeClr val="accent2"/>
+                </a:solidFill>
+              </a:rPr>
+              <a:t>軽いモダンから重いビンテージまで幅がある</a:t>
+            </a:r>
+            <a:endParaRPr lang="en-US" sz="1100" dirty="0"/>
+          </a:p>
+        </p:txBody>
+      </p:sp>
+      <p:sp>
+        <p:nvSpPr>
+          <p:cNvPr id="25" name="Slide Number Placeholder 0"/>
+          <p:cNvSpPr>
+            <a:spLocks noGrp="1"/>
+          </p:cNvSpPr>
+          <p:nvPr>
+            <p:ph type="sldNum" sz="quarter" idx="4294967295"/>
+          </p:nvPr>
+        </p:nvSpPr>
+        <p:spPr>
+          <a:xfrm>
+            <a:off x="8412480" y="4754880"/>
+            <a:ext cx="457200" cy="274320"/>
+          </a:xfrm>
+          <a:prstGeom prst="rect">
+            <a:avLst/>
+          </a:prstGeom>
+          <a:extLst>
+            <a:ext uri="{C572A759-6A51-4108-AA02-DFA0A04FC94B}">
+              <ma14:wrappingTextBoxFlag xmlns:ma14="http://schemas.microsoft.com/office/mac/drawingml/2011/main" val="0"/>
+            </a:ext>
+          </a:extLst>
+        </p:spPr>
+        <p:txBody>
+          <a:bodyPr/>
+          <a:lstStyle>
+            <a:lvl1pPr>
+              <a:defRPr sz="1000">
+                <a:solidFill>
+                  <a:schemeClr val="accent6"/>
+                </a:solidFill>
+              </a:defRPr>
+            </a:lvl1pPr>
+          </a:lstStyle>
+          <a:p>
+            <a:pPr algn="l"/>
+            <a:fld id="{F7021451-1387-4CA6-816F-3879F97B5CBC}" type="slidenum">
+              <a:rPr b="0" lang="en-US"/>
+              <a:t>12</a:t>
+            </a:fld>
+            <a:endParaRPr lang="en-US"/>
+          </a:p>
+        </p:txBody>
+      </p:sp>
+    </p:spTree>
+  </p:cSld>
+  <p:clrMapOvr>
+    <a:masterClrMapping/>
+  </p:clrMapOvr>
+</p:sld>
+</file>
+
+<file path=ppt/slides/slide13.xml><?xml version="1.0" encoding="utf-8"?>
+<p:sld xmlns:a="http://schemas.openxmlformats.org/drawingml/2006/main" xmlns:r="http://schemas.openxmlformats.org/officeDocument/2006/relationships" xmlns:p="http://schemas.openxmlformats.org/presentationml/2006/main">
+  <p:cSld name="Slide 13">
+    <p:spTree>
+      <p:nvGrpSpPr>
+        <p:cNvPr id="1" name=""/>
+        <p:cNvGrpSpPr/>
+        <p:nvPr/>
+      </p:nvGrpSpPr>
+      <p:grpSpPr>
+        <a:xfrm>
+          <a:off x="0" y="0"/>
+          <a:ext cx="0" cy="0"/>
+          <a:chOff x="0" y="0"/>
+          <a:chExt cx="0" cy="0"/>
+        </a:xfrm>
+      </p:grpSpPr>
+      <p:sp>
+        <p:nvSpPr>
+          <p:cNvPr id="2" name="part-tag"/>
+          <p:cNvSpPr txBox="1"/>
+          <p:nvPr/>
+        </p:nvSpPr>
+        <p:spPr>
+          <a:xfrm>
+            <a:off x="457200" y="73152"/>
+            <a:ext cx="3657600" cy="228600"/>
+          </a:xfrm>
+          <a:prstGeom prst="rect">
+            <a:avLst/>
+          </a:prstGeom>
+          <a:noFill/>
+          <a:ln/>
+        </p:spPr>
+        <p:txBody>
+          <a:bodyPr wrap="square" lIns="0" tIns="0" rIns="0" bIns="0" rtlCol="0" anchor="ctr"/>
+          <a:lstStyle/>
+          <a:p>
+            <a:pPr indent="0" marL="0">
+              <a:buNone/>
+            </a:pPr>
+            <a:r>
+              <a:rPr lang="en-US" sz="1100" b="1" dirty="0">
+                <a:solidFill>
+                  <a:schemeClr val="accent1"/>
+                </a:solidFill>
+              </a:rPr>
+              <a:t>④ グループワーク　15分</a:t>
+            </a:r>
+            <a:endParaRPr lang="en-US" sz="1100" dirty="0"/>
+          </a:p>
+        </p:txBody>
+      </p:sp>
+      <p:sp>
+        <p:nvSpPr>
+          <p:cNvPr id="3" name="Text 0"/>
+          <p:cNvSpPr/>
+          <p:nvPr>
+            <p:ph idx="100" type="title" hasCustomPrompt="1"/>
+          </p:nvPr>
+        </p:nvSpPr>
+        <p:spPr>
+          <a:xfrm>
+            <a:off x="457200" y="274320"/>
+            <a:ext cx="8229600" cy="640080"/>
+          </a:xfrm>
+          <a:prstGeom prst="rect">
+            <a:avLst/>
+          </a:prstGeom>
+          <a:noFill/>
+          <a:ln/>
+        </p:spPr>
+        <p:txBody>
+          <a:bodyPr wrap="square" lIns="0" tIns="0" rIns="0" bIns="0" rtlCol="0" anchor="ctr"/>
+          <a:lstStyle/>
+          <a:p>
+            <a:pPr algn="l" indent="0" marL="0">
+              <a:buNone/>
+            </a:pPr>
+            <a:r>
+              <a:rPr lang="en-US" sz="2600" b="1" dirty="0">
+                <a:solidFill>
+                  <a:schemeClr val="tx2"/>
+                </a:solidFill>
+              </a:rPr>
               <a:t>北欧といっても、定義を決めないといけない</a:t>
             </a:r>
             <a:endParaRPr lang="en-US" sz="2600" dirty="0"/>
@@ -3961,7 +4949,7 @@
       </p:sp>
       <p:graphicFrame>
         <p:nvGraphicFramePr>
-          <p:cNvPr id="13" name="define-sheet"/>
+          <p:cNvPr id="14" name="define-sheet"/>
           <p:cNvGraphicFramePr>
             <a:graphicFrameLocks noGrp="1"/>
           </p:cNvGraphicFramePr>
@@ -5442,904 +6430,6 @@
             <a:pPr algn="l"/>
             <a:fld id="{F7021451-1387-4CA6-816F-3879F97B5CBC}" type="slidenum">
               <a:rPr b="0" lang="en-US"/>
-              <a:t>12</a:t>
-            </a:fld>
-            <a:endParaRPr lang="en-US"/>
-          </a:p>
-        </p:txBody>
-      </p:sp>
-    </p:spTree>
-  </p:cSld>
-  <p:clrMapOvr>
-    <a:masterClrMapping/>
-  </p:clrMapOvr>
-</p:sld>
-</file>
-
-<file path=ppt/slides/slide13.xml><?xml version="1.0" encoding="utf-8"?>
-<p:sld xmlns:a="http://schemas.openxmlformats.org/drawingml/2006/main" xmlns:r="http://schemas.openxmlformats.org/officeDocument/2006/relationships" xmlns:p="http://schemas.openxmlformats.org/presentationml/2006/main">
-  <p:cSld name="Slide 13">
-    <p:spTree>
-      <p:nvGrpSpPr>
-        <p:cNvPr id="1" name=""/>
-        <p:cNvGrpSpPr/>
-        <p:nvPr/>
-      </p:nvGrpSpPr>
-      <p:grpSpPr>
-        <a:xfrm>
-          <a:off x="0" y="0"/>
-          <a:ext cx="0" cy="0"/>
-          <a:chOff x="0" y="0"/>
-          <a:chExt cx="0" cy="0"/>
-        </a:xfrm>
-      </p:grpSpPr>
-      <p:sp>
-        <p:nvSpPr>
-          <p:cNvPr id="2" name="part-tag"/>
-          <p:cNvSpPr txBox="1"/>
-          <p:nvPr/>
-        </p:nvSpPr>
-        <p:spPr>
-          <a:xfrm>
-            <a:off x="457200" y="73152"/>
-            <a:ext cx="3657600" cy="228600"/>
-          </a:xfrm>
-          <a:prstGeom prst="rect">
-            <a:avLst/>
-          </a:prstGeom>
-          <a:noFill/>
-          <a:ln/>
-        </p:spPr>
-        <p:txBody>
-          <a:bodyPr wrap="square" lIns="0" tIns="0" rIns="0" bIns="0" rtlCol="0" anchor="ctr"/>
-          <a:lstStyle/>
-          <a:p>
-            <a:pPr indent="0" marL="0">
-              <a:buNone/>
-            </a:pPr>
-            <a:r>
-              <a:rPr lang="en-US" sz="1100" b="1" dirty="0">
-                <a:solidFill>
-                  <a:schemeClr val="accent1"/>
-                </a:solidFill>
-              </a:rPr>
-              <a:t>⑤ グループワーク　25分</a:t>
-            </a:r>
-            <a:endParaRPr lang="en-US" sz="1100" dirty="0"/>
-          </a:p>
-        </p:txBody>
-      </p:sp>
-      <p:sp>
-        <p:nvSpPr>
-          <p:cNvPr id="3" name="Text 0"/>
-          <p:cNvSpPr/>
-          <p:nvPr>
-            <p:ph idx="100" type="title" hasCustomPrompt="1"/>
-          </p:nvPr>
-        </p:nvSpPr>
-        <p:spPr>
-          <a:xfrm>
-            <a:off x="457200" y="274320"/>
-            <a:ext cx="8229600" cy="640080"/>
-          </a:xfrm>
-          <a:prstGeom prst="rect">
-            <a:avLst/>
-          </a:prstGeom>
-          <a:noFill/>
-          <a:ln/>
-        </p:spPr>
-        <p:txBody>
-          <a:bodyPr wrap="square" lIns="0" tIns="0" rIns="0" bIns="0" rtlCol="0" anchor="ctr"/>
-          <a:lstStyle/>
-          <a:p>
-            <a:pPr algn="l" indent="0" marL="0">
-              <a:buNone/>
-            </a:pPr>
-            <a:r>
-              <a:rPr lang="en-US" sz="2600" b="1" dirty="0">
-                <a:solidFill>
-                  <a:schemeClr val="tx2"/>
-                </a:solidFill>
-              </a:rPr>
-              <a:t>自社商品はどこに集まり、どこがばらけているか</a:t>
-            </a:r>
-            <a:endParaRPr lang="en-US" sz="2600" dirty="0"/>
-          </a:p>
-        </p:txBody>
-      </p:sp>
-      <p:sp>
-        <p:nvSpPr>
-          <p:cNvPr id="4" name="matrix-bg"/>
-          <p:cNvSpPr/>
-          <p:nvPr/>
-        </p:nvSpPr>
-        <p:spPr>
-          <a:xfrm>
-            <a:off x="1097280" y="1051560"/>
-            <a:ext cx="6949440" cy="3566160"/>
-          </a:xfrm>
-          <a:prstGeom prst="rect">
-            <a:avLst/>
-          </a:prstGeom>
-          <a:solidFill>
-            <a:schemeClr val="bg2"/>
-          </a:solidFill>
-          <a:ln/>
-        </p:spPr>
-      </p:sp>
-      <p:sp>
-        <p:nvSpPr>
-          <p:cNvPr id="5" name="Shape 3"/>
-          <p:cNvSpPr/>
-          <p:nvPr/>
-        </p:nvSpPr>
-        <p:spPr>
-          <a:xfrm>
-            <a:off x="1097280" y="2834640"/>
-            <a:ext cx="6949440" cy="0"/>
-          </a:xfrm>
-          <a:prstGeom prst="line">
-            <a:avLst/>
-          </a:prstGeom>
-          <a:noFill/>
-          <a:ln w="19050">
-            <a:solidFill>
-              <a:schemeClr val="accent6"/>
-            </a:solidFill>
-            <a:prstDash val="solid"/>
-            <a:headEnd type="triangle"/>
-            <a:tailEnd type="triangle"/>
-          </a:ln>
-        </p:spPr>
-      </p:sp>
-      <p:sp>
-        <p:nvSpPr>
-          <p:cNvPr id="6" name="Shape 4"/>
-          <p:cNvSpPr/>
-          <p:nvPr/>
-        </p:nvSpPr>
-        <p:spPr>
-          <a:xfrm>
-            <a:off x="4572000" y="1051560"/>
-            <a:ext cx="0" cy="3566160"/>
-          </a:xfrm>
-          <a:prstGeom prst="line">
-            <a:avLst/>
-          </a:prstGeom>
-          <a:noFill/>
-          <a:ln w="19050">
-            <a:solidFill>
-              <a:schemeClr val="accent6"/>
-            </a:solidFill>
-            <a:prstDash val="solid"/>
-            <a:headEnd type="triangle"/>
-            <a:tailEnd type="triangle"/>
-          </a:ln>
-        </p:spPr>
-      </p:sp>
-      <p:sp>
-        <p:nvSpPr>
-          <p:cNvPr id="7" name="Text 5"/>
-          <p:cNvSpPr txBox="1"/>
-          <p:nvPr/>
-        </p:nvSpPr>
-        <p:spPr>
-          <a:xfrm>
-            <a:off x="1188720" y="2907792"/>
-            <a:ext cx="1828800" cy="274320"/>
-          </a:xfrm>
-          <a:prstGeom prst="rect">
-            <a:avLst/>
-          </a:prstGeom>
-          <a:noFill/>
-          <a:ln/>
-        </p:spPr>
-        <p:txBody>
-          <a:bodyPr wrap="square" lIns="0" tIns="0" rIns="0" bIns="0" rtlCol="0" anchor="ctr"/>
-          <a:lstStyle/>
-          <a:p>
-            <a:pPr algn="l" indent="0" marL="0">
-              <a:buNone/>
-            </a:pPr>
-            <a:r>
-              <a:rPr lang="en-US" sz="1200" b="1" dirty="0">
-                <a:solidFill>
-                  <a:schemeClr val="tx2"/>
-                </a:solidFill>
-              </a:rPr>
-              <a:t>トラディショナル</a:t>
-            </a:r>
-            <a:endParaRPr lang="en-US" sz="1200" dirty="0"/>
-          </a:p>
-        </p:txBody>
-      </p:sp>
-      <p:sp>
-        <p:nvSpPr>
-          <p:cNvPr id="8" name="Text 6"/>
-          <p:cNvSpPr txBox="1"/>
-          <p:nvPr/>
-        </p:nvSpPr>
-        <p:spPr>
-          <a:xfrm>
-            <a:off x="6126480" y="2907792"/>
-            <a:ext cx="1828800" cy="274320"/>
-          </a:xfrm>
-          <a:prstGeom prst="rect">
-            <a:avLst/>
-          </a:prstGeom>
-          <a:noFill/>
-          <a:ln/>
-        </p:spPr>
-        <p:txBody>
-          <a:bodyPr wrap="square" lIns="0" tIns="0" rIns="0" bIns="0" rtlCol="0" anchor="ctr"/>
-          <a:lstStyle/>
-          <a:p>
-            <a:pPr algn="r" indent="0" marL="0">
-              <a:buNone/>
-            </a:pPr>
-            <a:r>
-              <a:rPr lang="en-US" sz="1200" b="1" dirty="0">
-                <a:solidFill>
-                  <a:schemeClr val="tx2"/>
-                </a:solidFill>
-              </a:rPr>
-              <a:t>モダン</a:t>
-            </a:r>
-            <a:endParaRPr lang="en-US" sz="1200" dirty="0"/>
-          </a:p>
-        </p:txBody>
-      </p:sp>
-      <p:sp>
-        <p:nvSpPr>
-          <p:cNvPr id="9" name="Text 7"/>
-          <p:cNvSpPr txBox="1"/>
-          <p:nvPr/>
-        </p:nvSpPr>
-        <p:spPr>
-          <a:xfrm>
-            <a:off x="4663440" y="1124712"/>
-            <a:ext cx="2743200" cy="274320"/>
-          </a:xfrm>
-          <a:prstGeom prst="rect">
-            <a:avLst/>
-          </a:prstGeom>
-          <a:noFill/>
-          <a:ln/>
-        </p:spPr>
-        <p:txBody>
-          <a:bodyPr wrap="square" lIns="0" tIns="0" rIns="0" bIns="0" rtlCol="0" anchor="ctr"/>
-          <a:lstStyle/>
-          <a:p>
-            <a:pPr algn="l" indent="0" marL="0">
-              <a:buNone/>
-            </a:pPr>
-            <a:r>
-              <a:rPr lang="en-US" sz="1200" b="1" dirty="0">
-                <a:solidFill>
-                  <a:schemeClr val="tx2"/>
-                </a:solidFill>
-              </a:rPr>
-              <a:t>軽い（淡い色・細い脚）</a:t>
-            </a:r>
-            <a:endParaRPr lang="en-US" sz="1200" dirty="0"/>
-          </a:p>
-        </p:txBody>
-      </p:sp>
-      <p:sp>
-        <p:nvSpPr>
-          <p:cNvPr id="10" name="Text 8"/>
-          <p:cNvSpPr txBox="1"/>
-          <p:nvPr/>
-        </p:nvSpPr>
-        <p:spPr>
-          <a:xfrm>
-            <a:off x="4663440" y="4270248"/>
-            <a:ext cx="2743200" cy="274320"/>
-          </a:xfrm>
-          <a:prstGeom prst="rect">
-            <a:avLst/>
-          </a:prstGeom>
-          <a:noFill/>
-          <a:ln/>
-        </p:spPr>
-        <p:txBody>
-          <a:bodyPr wrap="square" lIns="0" tIns="0" rIns="0" bIns="0" rtlCol="0" anchor="ctr"/>
-          <a:lstStyle/>
-          <a:p>
-            <a:pPr algn="l" indent="0" marL="0">
-              <a:buNone/>
-            </a:pPr>
-            <a:r>
-              <a:rPr lang="en-US" sz="1200" b="1" dirty="0">
-                <a:solidFill>
-                  <a:schemeClr val="tx2"/>
-                </a:solidFill>
-              </a:rPr>
-              <a:t>重い（濃い色・量感・装飾）</a:t>
-            </a:r>
-            <a:endParaRPr lang="en-US" sz="1200" dirty="0"/>
-          </a:p>
-        </p:txBody>
-      </p:sp>
-      <p:sp>
-        <p:nvSpPr>
-          <p:cNvPr id="11" name="Shape 9"/>
-          <p:cNvSpPr/>
-          <p:nvPr/>
-        </p:nvSpPr>
-        <p:spPr>
-          <a:xfrm>
-            <a:off x="5303520" y="1554480"/>
-            <a:ext cx="1463040" cy="365760"/>
-          </a:xfrm>
-          <a:prstGeom prst="roundRect">
-            <a:avLst>
-              <a:gd name="adj" fmla="val 50000"/>
-            </a:avLst>
-          </a:prstGeom>
-          <a:solidFill>
-            <a:schemeClr val="tx2"/>
-          </a:solidFill>
-          <a:ln w="9525">
-            <a:solidFill>
-              <a:schemeClr val="tx2"/>
-            </a:solidFill>
-            <a:prstDash val="solid"/>
-          </a:ln>
-        </p:spPr>
-      </p:sp>
-      <p:sp>
-        <p:nvSpPr>
-          <p:cNvPr id="12" name="Text 10"/>
-          <p:cNvSpPr txBox="1"/>
-          <p:nvPr/>
-        </p:nvSpPr>
-        <p:spPr>
-          <a:xfrm>
-            <a:off x="5303520" y="1554480"/>
-            <a:ext cx="1463040" cy="365760"/>
-          </a:xfrm>
-          <a:prstGeom prst="rect">
-            <a:avLst/>
-          </a:prstGeom>
-          <a:noFill/>
-          <a:ln/>
-        </p:spPr>
-        <p:txBody>
-          <a:bodyPr wrap="square" lIns="0" tIns="0" rIns="0" bIns="0" rtlCol="0" anchor="ctr"/>
-          <a:lstStyle/>
-          <a:p>
-            <a:pPr algn="ctr" indent="0" marL="0">
-              <a:buNone/>
-            </a:pPr>
-            <a:r>
-              <a:rPr lang="en-US" sz="1100" b="1" dirty="0">
-                <a:solidFill>
-                  <a:schemeClr val="bg1"/>
-                </a:solidFill>
-              </a:rPr>
-              <a:t>北欧モダン</a:t>
-            </a:r>
-            <a:endParaRPr lang="en-US" sz="1100" dirty="0"/>
-          </a:p>
-        </p:txBody>
-      </p:sp>
-      <p:sp>
-        <p:nvSpPr>
-          <p:cNvPr id="13" name="Shape 11"/>
-          <p:cNvSpPr/>
-          <p:nvPr/>
-        </p:nvSpPr>
-        <p:spPr>
-          <a:xfrm>
-            <a:off x="6035040" y="2103120"/>
-            <a:ext cx="1463040" cy="365760"/>
-          </a:xfrm>
-          <a:prstGeom prst="roundRect">
-            <a:avLst>
-              <a:gd name="adj" fmla="val 50000"/>
-            </a:avLst>
-          </a:prstGeom>
-          <a:solidFill>
-            <a:schemeClr val="bg1"/>
-          </a:solidFill>
-          <a:ln w="9525">
-            <a:solidFill>
-              <a:schemeClr val="accent6"/>
-            </a:solidFill>
-            <a:prstDash val="dash"/>
-          </a:ln>
-        </p:spPr>
-      </p:sp>
-      <p:sp>
-        <p:nvSpPr>
-          <p:cNvPr id="14" name="Text 12"/>
-          <p:cNvSpPr txBox="1"/>
-          <p:nvPr/>
-        </p:nvSpPr>
-        <p:spPr>
-          <a:xfrm>
-            <a:off x="6035040" y="2103120"/>
-            <a:ext cx="1463040" cy="365760"/>
-          </a:xfrm>
-          <a:prstGeom prst="rect">
-            <a:avLst/>
-          </a:prstGeom>
-          <a:noFill/>
-          <a:ln/>
-        </p:spPr>
-        <p:txBody>
-          <a:bodyPr wrap="square" lIns="0" tIns="0" rIns="0" bIns="0" rtlCol="0" anchor="ctr"/>
-          <a:lstStyle/>
-          <a:p>
-            <a:pPr algn="ctr" indent="0" marL="0">
-              <a:buNone/>
-            </a:pPr>
-            <a:r>
-              <a:rPr lang="en-US" sz="1100" dirty="0">
-                <a:solidFill>
-                  <a:schemeClr val="tx1"/>
-                </a:solidFill>
-              </a:rPr>
-              <a:t>ナチュラル</a:t>
-            </a:r>
-            <a:endParaRPr lang="en-US" sz="1100" dirty="0"/>
-          </a:p>
-        </p:txBody>
-      </p:sp>
-      <p:sp>
-        <p:nvSpPr>
-          <p:cNvPr id="15" name="Shape 13"/>
-          <p:cNvSpPr/>
-          <p:nvPr/>
-        </p:nvSpPr>
-        <p:spPr>
-          <a:xfrm>
-            <a:off x="5303520" y="3337560"/>
-            <a:ext cx="1463040" cy="365760"/>
-          </a:xfrm>
-          <a:prstGeom prst="roundRect">
-            <a:avLst>
-              <a:gd name="adj" fmla="val 50000"/>
-            </a:avLst>
-          </a:prstGeom>
-          <a:solidFill>
-            <a:schemeClr val="bg1"/>
-          </a:solidFill>
-          <a:ln w="9525">
-            <a:solidFill>
-              <a:schemeClr val="accent6"/>
-            </a:solidFill>
-            <a:prstDash val="dash"/>
-          </a:ln>
-        </p:spPr>
-      </p:sp>
-      <p:sp>
-        <p:nvSpPr>
-          <p:cNvPr id="16" name="Text 14"/>
-          <p:cNvSpPr txBox="1"/>
-          <p:nvPr/>
-        </p:nvSpPr>
-        <p:spPr>
-          <a:xfrm>
-            <a:off x="5303520" y="3337560"/>
-            <a:ext cx="1463040" cy="365760"/>
-          </a:xfrm>
-          <a:prstGeom prst="rect">
-            <a:avLst/>
-          </a:prstGeom>
-          <a:noFill/>
-          <a:ln/>
-        </p:spPr>
-        <p:txBody>
-          <a:bodyPr wrap="square" lIns="0" tIns="0" rIns="0" bIns="0" rtlCol="0" anchor="ctr"/>
-          <a:lstStyle/>
-          <a:p>
-            <a:pPr algn="ctr" indent="0" marL="0">
-              <a:buNone/>
-            </a:pPr>
-            <a:r>
-              <a:rPr lang="en-US" sz="1100" dirty="0">
-                <a:solidFill>
-                  <a:schemeClr val="tx1"/>
-                </a:solidFill>
-              </a:rPr>
-              <a:t>インダストリアル</a:t>
-            </a:r>
-            <a:endParaRPr lang="en-US" sz="1100" dirty="0"/>
-          </a:p>
-        </p:txBody>
-      </p:sp>
-      <p:sp>
-        <p:nvSpPr>
-          <p:cNvPr id="17" name="Shape 15"/>
-          <p:cNvSpPr/>
-          <p:nvPr/>
-        </p:nvSpPr>
-        <p:spPr>
-          <a:xfrm>
-            <a:off x="6035040" y="3886200"/>
-            <a:ext cx="1463040" cy="365760"/>
-          </a:xfrm>
-          <a:prstGeom prst="roundRect">
-            <a:avLst>
-              <a:gd name="adj" fmla="val 50000"/>
-            </a:avLst>
-          </a:prstGeom>
-          <a:solidFill>
-            <a:schemeClr val="bg1"/>
-          </a:solidFill>
-          <a:ln w="9525">
-            <a:solidFill>
-              <a:schemeClr val="accent6"/>
-            </a:solidFill>
-            <a:prstDash val="dash"/>
-          </a:ln>
-        </p:spPr>
-      </p:sp>
-      <p:sp>
-        <p:nvSpPr>
-          <p:cNvPr id="18" name="Text 16"/>
-          <p:cNvSpPr txBox="1"/>
-          <p:nvPr/>
-        </p:nvSpPr>
-        <p:spPr>
-          <a:xfrm>
-            <a:off x="6035040" y="3886200"/>
-            <a:ext cx="1463040" cy="365760"/>
-          </a:xfrm>
-          <a:prstGeom prst="rect">
-            <a:avLst/>
-          </a:prstGeom>
-          <a:noFill/>
-          <a:ln/>
-        </p:spPr>
-        <p:txBody>
-          <a:bodyPr wrap="square" lIns="0" tIns="0" rIns="0" bIns="0" rtlCol="0" anchor="ctr"/>
-          <a:lstStyle/>
-          <a:p>
-            <a:pPr algn="ctr" indent="0" marL="0">
-              <a:buNone/>
-            </a:pPr>
-            <a:r>
-              <a:rPr lang="en-US" sz="1100" dirty="0">
-                <a:solidFill>
-                  <a:schemeClr val="tx1"/>
-                </a:solidFill>
-              </a:rPr>
-              <a:t>イタリアンモダン</a:t>
-            </a:r>
-            <a:endParaRPr lang="en-US" sz="1100" dirty="0"/>
-          </a:p>
-        </p:txBody>
-      </p:sp>
-      <p:sp>
-        <p:nvSpPr>
-          <p:cNvPr id="19" name="Shape 17"/>
-          <p:cNvSpPr/>
-          <p:nvPr/>
-        </p:nvSpPr>
-        <p:spPr>
-          <a:xfrm>
-            <a:off x="1828800" y="1554480"/>
-            <a:ext cx="1463040" cy="365760"/>
-          </a:xfrm>
-          <a:prstGeom prst="roundRect">
-            <a:avLst>
-              <a:gd name="adj" fmla="val 50000"/>
-            </a:avLst>
-          </a:prstGeom>
-          <a:solidFill>
-            <a:schemeClr val="bg1"/>
-          </a:solidFill>
-          <a:ln w="9525">
-            <a:solidFill>
-              <a:schemeClr val="accent6"/>
-            </a:solidFill>
-            <a:prstDash val="dash"/>
-          </a:ln>
-        </p:spPr>
-      </p:sp>
-      <p:sp>
-        <p:nvSpPr>
-          <p:cNvPr id="20" name="Text 18"/>
-          <p:cNvSpPr txBox="1"/>
-          <p:nvPr/>
-        </p:nvSpPr>
-        <p:spPr>
-          <a:xfrm>
-            <a:off x="1828800" y="1554480"/>
-            <a:ext cx="1463040" cy="365760"/>
-          </a:xfrm>
-          <a:prstGeom prst="rect">
-            <a:avLst/>
-          </a:prstGeom>
-          <a:noFill/>
-          <a:ln/>
-        </p:spPr>
-        <p:txBody>
-          <a:bodyPr wrap="square" lIns="0" tIns="0" rIns="0" bIns="0" rtlCol="0" anchor="ctr"/>
-          <a:lstStyle/>
-          <a:p>
-            <a:pPr algn="ctr" indent="0" marL="0">
-              <a:buNone/>
-            </a:pPr>
-            <a:r>
-              <a:rPr lang="en-US" sz="1100" dirty="0">
-                <a:solidFill>
-                  <a:schemeClr val="tx1"/>
-                </a:solidFill>
-              </a:rPr>
-              <a:t>フレンチカントリー</a:t>
-            </a:r>
-            <a:endParaRPr lang="en-US" sz="1100" dirty="0"/>
-          </a:p>
-        </p:txBody>
-      </p:sp>
-      <p:sp>
-        <p:nvSpPr>
-          <p:cNvPr id="21" name="Shape 19"/>
-          <p:cNvSpPr/>
-          <p:nvPr/>
-        </p:nvSpPr>
-        <p:spPr>
-          <a:xfrm>
-            <a:off x="2377440" y="2103120"/>
-            <a:ext cx="1463040" cy="365760"/>
-          </a:xfrm>
-          <a:prstGeom prst="roundRect">
-            <a:avLst>
-              <a:gd name="adj" fmla="val 50000"/>
-            </a:avLst>
-          </a:prstGeom>
-          <a:solidFill>
-            <a:schemeClr val="bg1"/>
-          </a:solidFill>
-          <a:ln w="9525">
-            <a:solidFill>
-              <a:schemeClr val="accent6"/>
-            </a:solidFill>
-            <a:prstDash val="dash"/>
-          </a:ln>
-        </p:spPr>
-      </p:sp>
-      <p:sp>
-        <p:nvSpPr>
-          <p:cNvPr id="22" name="Text 20"/>
-          <p:cNvSpPr txBox="1"/>
-          <p:nvPr/>
-        </p:nvSpPr>
-        <p:spPr>
-          <a:xfrm>
-            <a:off x="2377440" y="2103120"/>
-            <a:ext cx="1463040" cy="365760"/>
-          </a:xfrm>
-          <a:prstGeom prst="rect">
-            <a:avLst/>
-          </a:prstGeom>
-          <a:noFill/>
-          <a:ln/>
-        </p:spPr>
-        <p:txBody>
-          <a:bodyPr wrap="square" lIns="0" tIns="0" rIns="0" bIns="0" rtlCol="0" anchor="ctr"/>
-          <a:lstStyle/>
-          <a:p>
-            <a:pPr algn="ctr" indent="0" marL="0">
-              <a:buNone/>
-            </a:pPr>
-            <a:r>
-              <a:rPr lang="en-US" sz="1100" dirty="0">
-                <a:solidFill>
-                  <a:schemeClr val="tx1"/>
-                </a:solidFill>
-              </a:rPr>
-              <a:t>ロココ</a:t>
-            </a:r>
-            <a:endParaRPr lang="en-US" sz="1100" dirty="0"/>
-          </a:p>
-        </p:txBody>
-      </p:sp>
-      <p:sp>
-        <p:nvSpPr>
-          <p:cNvPr id="23" name="Shape 21"/>
-          <p:cNvSpPr/>
-          <p:nvPr/>
-        </p:nvSpPr>
-        <p:spPr>
-          <a:xfrm>
-            <a:off x="1828800" y="3337560"/>
-            <a:ext cx="1463040" cy="365760"/>
-          </a:xfrm>
-          <a:prstGeom prst="roundRect">
-            <a:avLst>
-              <a:gd name="adj" fmla="val 50000"/>
-            </a:avLst>
-          </a:prstGeom>
-          <a:solidFill>
-            <a:schemeClr val="bg1"/>
-          </a:solidFill>
-          <a:ln w="9525">
-            <a:solidFill>
-              <a:schemeClr val="accent6"/>
-            </a:solidFill>
-            <a:prstDash val="dash"/>
-          </a:ln>
-        </p:spPr>
-      </p:sp>
-      <p:sp>
-        <p:nvSpPr>
-          <p:cNvPr id="24" name="Text 22"/>
-          <p:cNvSpPr txBox="1"/>
-          <p:nvPr/>
-        </p:nvSpPr>
-        <p:spPr>
-          <a:xfrm>
-            <a:off x="1828800" y="3337560"/>
-            <a:ext cx="1463040" cy="365760"/>
-          </a:xfrm>
-          <a:prstGeom prst="rect">
-            <a:avLst/>
-          </a:prstGeom>
-          <a:noFill/>
-          <a:ln/>
-        </p:spPr>
-        <p:txBody>
-          <a:bodyPr wrap="square" lIns="0" tIns="0" rIns="0" bIns="0" rtlCol="0" anchor="ctr"/>
-          <a:lstStyle/>
-          <a:p>
-            <a:pPr algn="ctr" indent="0" marL="0">
-              <a:buNone/>
-            </a:pPr>
-            <a:r>
-              <a:rPr lang="en-US" sz="1100" dirty="0">
-                <a:solidFill>
-                  <a:schemeClr val="tx1"/>
-                </a:solidFill>
-              </a:rPr>
-              <a:t>ヴィクトリアン</a:t>
-            </a:r>
-            <a:endParaRPr lang="en-US" sz="1100" dirty="0"/>
-          </a:p>
-        </p:txBody>
-      </p:sp>
-      <p:sp>
-        <p:nvSpPr>
-          <p:cNvPr id="25" name="Shape 23"/>
-          <p:cNvSpPr/>
-          <p:nvPr/>
-        </p:nvSpPr>
-        <p:spPr>
-          <a:xfrm>
-            <a:off x="2377440" y="3886200"/>
-            <a:ext cx="1463040" cy="365760"/>
-          </a:xfrm>
-          <a:prstGeom prst="roundRect">
-            <a:avLst>
-              <a:gd name="adj" fmla="val 50000"/>
-            </a:avLst>
-          </a:prstGeom>
-          <a:solidFill>
-            <a:schemeClr val="bg1"/>
-          </a:solidFill>
-          <a:ln w="9525">
-            <a:solidFill>
-              <a:schemeClr val="accent6"/>
-            </a:solidFill>
-            <a:prstDash val="dash"/>
-          </a:ln>
-        </p:spPr>
-      </p:sp>
-      <p:sp>
-        <p:nvSpPr>
-          <p:cNvPr id="26" name="Text 24"/>
-          <p:cNvSpPr txBox="1"/>
-          <p:nvPr/>
-        </p:nvSpPr>
-        <p:spPr>
-          <a:xfrm>
-            <a:off x="2377440" y="3886200"/>
-            <a:ext cx="1463040" cy="365760"/>
-          </a:xfrm>
-          <a:prstGeom prst="rect">
-            <a:avLst/>
-          </a:prstGeom>
-          <a:noFill/>
-          <a:ln/>
-        </p:spPr>
-        <p:txBody>
-          <a:bodyPr wrap="square" lIns="0" tIns="0" rIns="0" bIns="0" rtlCol="0" anchor="ctr"/>
-          <a:lstStyle/>
-          <a:p>
-            <a:pPr algn="ctr" indent="0" marL="0">
-              <a:buNone/>
-            </a:pPr>
-            <a:r>
-              <a:rPr lang="en-US" sz="1100" dirty="0">
-                <a:solidFill>
-                  <a:schemeClr val="tx1"/>
-                </a:solidFill>
-              </a:rPr>
-              <a:t>バロック</a:t>
-            </a:r>
-            <a:endParaRPr lang="en-US" sz="1100" dirty="0"/>
-          </a:p>
-        </p:txBody>
-      </p:sp>
-      <p:sp>
-        <p:nvSpPr>
-          <p:cNvPr id="27" name="Text 25"/>
-          <p:cNvSpPr txBox="1"/>
-          <p:nvPr/>
-        </p:nvSpPr>
-        <p:spPr>
-          <a:xfrm>
-            <a:off x="457200" y="4709160"/>
-            <a:ext cx="5486400" cy="274320"/>
-          </a:xfrm>
-          <a:prstGeom prst="rect">
-            <a:avLst/>
-          </a:prstGeom>
-          <a:noFill/>
-          <a:ln/>
-        </p:spPr>
-        <p:txBody>
-          <a:bodyPr wrap="square" lIns="0" tIns="0" rIns="0" bIns="0" rtlCol="0" anchor="ctr"/>
-          <a:lstStyle/>
-          <a:p>
-            <a:pPr indent="0" marL="0">
-              <a:buNone/>
-            </a:pPr>
-            <a:r>
-              <a:rPr lang="en-US" sz="1000" dirty="0">
-                <a:solidFill>
-                  <a:schemeClr val="accent6"/>
-                </a:solidFill>
-              </a:rPr>
-              <a:t>点線は位置の例（当日の議論で動かしてOK）</a:t>
-            </a:r>
-            <a:endParaRPr lang="en-US" sz="1000" dirty="0"/>
-          </a:p>
-        </p:txBody>
-      </p:sp>
-      <p:sp>
-        <p:nvSpPr>
-          <p:cNvPr id="25" name="Slide Number Placeholder 0"/>
-          <p:cNvSpPr>
-            <a:spLocks noGrp="1"/>
-          </p:cNvSpPr>
-          <p:nvPr>
-            <p:ph type="sldNum" sz="quarter" idx="4294967295"/>
-          </p:nvPr>
-        </p:nvSpPr>
-        <p:spPr>
-          <a:xfrm>
-            <a:off x="8412480" y="4754880"/>
-            <a:ext cx="457200" cy="274320"/>
-          </a:xfrm>
-          <a:prstGeom prst="rect">
-            <a:avLst/>
-          </a:prstGeom>
-          <a:extLst>
-            <a:ext uri="{C572A759-6A51-4108-AA02-DFA0A04FC94B}">
-              <ma14:wrappingTextBoxFlag xmlns:ma14="http://schemas.microsoft.com/office/mac/drawingml/2011/main" val="0"/>
-            </a:ext>
-          </a:extLst>
-        </p:spPr>
-        <p:txBody>
-          <a:bodyPr/>
-          <a:lstStyle>
-            <a:lvl1pPr>
-              <a:defRPr sz="1000">
-                <a:solidFill>
-                  <a:schemeClr val="accent6"/>
-                </a:solidFill>
-              </a:defRPr>
-            </a:lvl1pPr>
-          </a:lstStyle>
-          <a:p>
-            <a:pPr algn="l"/>
-            <a:fld id="{F7021451-1387-4CA6-816F-3879F97B5CBC}" type="slidenum">
-              <a:rPr b="0" lang="en-US"/>
               <a:t>13</a:t>
             </a:fld>
             <a:endParaRPr lang="en-US"/>
@@ -6401,7 +6491,7 @@
                   <a:schemeClr val="accent1"/>
                 </a:solidFill>
               </a:rPr>
-              <a:t>⑤ グループワーク</a:t>
+              <a:t>⑤ グループワーク　25分</a:t>
             </a:r>
             <a:endParaRPr lang="en-US" sz="1100" dirty="0"/>
           </a:p>
@@ -6439,7 +6529,7 @@
                   <a:schemeClr val="tx2"/>
                 </a:solidFill>
               </a:rPr>
-              <a:t>ワークの進め方</a:t>
+              <a:t>自社商品はどこに集まり、どこがばらけているか</a:t>
             </a:r>
             <a:endParaRPr lang="en-US" sz="2600" dirty="0"/>
           </a:p>
@@ -6447,19 +6537,17 @@
       </p:sp>
       <p:sp>
         <p:nvSpPr>
-          <p:cNvPr id="4" name="step-0"/>
+          <p:cNvPr id="4" name="matrix-bg"/>
           <p:cNvSpPr/>
           <p:nvPr/>
         </p:nvSpPr>
         <p:spPr>
           <a:xfrm>
-            <a:off x="457200" y="1188720"/>
-            <a:ext cx="2606040" cy="2743200"/>
-          </a:xfrm>
-          <a:prstGeom prst="roundRect">
-            <a:avLst>
-              <a:gd name="adj" fmla="val 4211"/>
-            </a:avLst>
+            <a:off x="1097280" y="1051560"/>
+            <a:ext cx="6949440" cy="3566160"/>
+          </a:xfrm>
+          <a:prstGeom prst="rect">
+            <a:avLst/>
           </a:prstGeom>
           <a:solidFill>
             <a:schemeClr val="bg2"/>
@@ -6469,75 +6557,53 @@
       </p:sp>
       <p:sp>
         <p:nvSpPr>
-          <p:cNvPr id="5" name="Text 3"/>
-          <p:cNvSpPr txBox="1"/>
-          <p:nvPr/>
-        </p:nvSpPr>
-        <p:spPr>
-          <a:xfrm>
-            <a:off x="685800" y="1371600"/>
-            <a:ext cx="1371600" cy="274320"/>
-          </a:xfrm>
-          <a:prstGeom prst="rect">
-            <a:avLst/>
-          </a:prstGeom>
-          <a:noFill/>
-          <a:ln/>
-        </p:spPr>
-        <p:txBody>
-          <a:bodyPr wrap="square" lIns="0" tIns="0" rIns="0" bIns="0" rtlCol="0" anchor="ctr"/>
-          <a:lstStyle/>
-          <a:p>
-            <a:pPr indent="0" marL="0">
-              <a:buNone/>
-            </a:pPr>
-            <a:r>
-              <a:rPr lang="en-US" sz="1100" b="1" dirty="0">
-                <a:solidFill>
-                  <a:schemeClr val="accent1"/>
-                </a:solidFill>
-              </a:rPr>
-              <a:t>STEP 1</a:t>
-            </a:r>
-            <a:endParaRPr lang="en-US" sz="1100" dirty="0"/>
-          </a:p>
-        </p:txBody>
-      </p:sp>
-      <p:sp>
-        <p:nvSpPr>
-          <p:cNvPr id="6" name="Text 4"/>
-          <p:cNvSpPr txBox="1"/>
-          <p:nvPr/>
-        </p:nvSpPr>
-        <p:spPr>
-          <a:xfrm>
-            <a:off x="1920240" y="1371600"/>
-            <a:ext cx="914400" cy="274320"/>
-          </a:xfrm>
-          <a:prstGeom prst="rect">
-            <a:avLst/>
-          </a:prstGeom>
-          <a:noFill/>
-          <a:ln/>
-        </p:spPr>
-        <p:txBody>
-          <a:bodyPr wrap="square" lIns="0" tIns="0" rIns="0" bIns="0" rtlCol="0" anchor="ctr"/>
-          <a:lstStyle/>
-          <a:p>
-            <a:pPr algn="r" indent="0" marL="0">
-              <a:buNone/>
-            </a:pPr>
-            <a:r>
-              <a:rPr lang="en-US" sz="1100" dirty="0">
-                <a:solidFill>
-                  <a:schemeClr val="accent6"/>
-                </a:solidFill>
-              </a:rPr>
-              <a:t>10分</a:t>
-            </a:r>
-            <a:endParaRPr lang="en-US" sz="1100" dirty="0"/>
-          </a:p>
-        </p:txBody>
+          <p:cNvPr id="5" name="Shape 3"/>
+          <p:cNvSpPr/>
+          <p:nvPr/>
+        </p:nvSpPr>
+        <p:spPr>
+          <a:xfrm>
+            <a:off x="1097280" y="2834640"/>
+            <a:ext cx="6949440" cy="0"/>
+          </a:xfrm>
+          <a:prstGeom prst="line">
+            <a:avLst/>
+          </a:prstGeom>
+          <a:noFill/>
+          <a:ln w="19050">
+            <a:solidFill>
+              <a:schemeClr val="accent6"/>
+            </a:solidFill>
+            <a:prstDash val="solid"/>
+            <a:headEnd type="triangle"/>
+            <a:tailEnd type="triangle"/>
+          </a:ln>
+        </p:spPr>
+      </p:sp>
+      <p:sp>
+        <p:nvSpPr>
+          <p:cNvPr id="6" name="Shape 4"/>
+          <p:cNvSpPr/>
+          <p:nvPr/>
+        </p:nvSpPr>
+        <p:spPr>
+          <a:xfrm>
+            <a:off x="4572000" y="1051560"/>
+            <a:ext cx="0" cy="3566160"/>
+          </a:xfrm>
+          <a:prstGeom prst="line">
+            <a:avLst/>
+          </a:prstGeom>
+          <a:noFill/>
+          <a:ln w="19050">
+            <a:solidFill>
+              <a:schemeClr val="accent6"/>
+            </a:solidFill>
+            <a:prstDash val="solid"/>
+            <a:headEnd type="triangle"/>
+            <a:tailEnd type="triangle"/>
+          </a:ln>
+        </p:spPr>
       </p:sp>
       <p:sp>
         <p:nvSpPr>
@@ -6547,8 +6613,8 @@
         </p:nvSpPr>
         <p:spPr>
           <a:xfrm>
-            <a:off x="685800" y="1737360"/>
-            <a:ext cx="2148840" cy="457200"/>
+            <a:off x="1188720" y="2907792"/>
+            <a:ext cx="1828800" cy="274320"/>
           </a:xfrm>
           <a:prstGeom prst="rect">
             <a:avLst/>
@@ -6560,18 +6626,18 @@
           <a:bodyPr wrap="square" lIns="0" tIns="0" rIns="0" bIns="0" rtlCol="0" anchor="ctr"/>
           <a:lstStyle/>
           <a:p>
-            <a:pPr indent="0" marL="0">
-              <a:buNone/>
-            </a:pPr>
-            <a:r>
-              <a:rPr lang="en-US" sz="2000" b="1" dirty="0">
+            <a:pPr algn="l" indent="0" marL="0">
+              <a:buNone/>
+            </a:pPr>
+            <a:r>
+              <a:rPr lang="en-US" sz="1200" b="1" dirty="0">
                 <a:solidFill>
                   <a:schemeClr val="tx2"/>
                 </a:solidFill>
               </a:rPr>
-              <a:t>書き出す</a:t>
-            </a:r>
-            <a:endParaRPr lang="en-US" sz="2000" dirty="0"/>
+              <a:t>トラディショナル</a:t>
+            </a:r>
+            <a:endParaRPr lang="en-US" sz="1200" dirty="0"/>
           </a:p>
         </p:txBody>
       </p:sp>
@@ -6583,127 +6649,132 @@
         </p:nvSpPr>
         <p:spPr>
           <a:xfrm>
-            <a:off x="685800" y="2331720"/>
-            <a:ext cx="2148840" cy="1463040"/>
-          </a:xfrm>
-          <a:prstGeom prst="rect">
-            <a:avLst/>
-          </a:prstGeom>
-          <a:noFill/>
-          <a:ln/>
-        </p:spPr>
-        <p:txBody>
-          <a:bodyPr wrap="square" lIns="0" tIns="0" rIns="0" bIns="0" rtlCol="0" anchor="t"/>
-          <a:lstStyle/>
-          <a:p>
-            <a:pPr indent="0" marL="0">
-              <a:buNone/>
-            </a:pPr>
-            <a:r>
-              <a:rPr lang="en-US" sz="1300" dirty="0">
-                <a:solidFill>
-                  <a:schemeClr val="tx1"/>
-                </a:solidFill>
-              </a:rPr>
-              <a:t>商品開発部の商品を書き出し、各商品が「どのスタイルか」を付箋に書く</a:t>
-            </a:r>
-            <a:endParaRPr lang="en-US" sz="1300" dirty="0"/>
-          </a:p>
-        </p:txBody>
-      </p:sp>
-      <p:sp>
-        <p:nvSpPr>
-          <p:cNvPr id="9" name="step-1"/>
+            <a:off x="6126480" y="2907792"/>
+            <a:ext cx="1828800" cy="274320"/>
+          </a:xfrm>
+          <a:prstGeom prst="rect">
+            <a:avLst/>
+          </a:prstGeom>
+          <a:noFill/>
+          <a:ln/>
+        </p:spPr>
+        <p:txBody>
+          <a:bodyPr wrap="square" lIns="0" tIns="0" rIns="0" bIns="0" rtlCol="0" anchor="ctr"/>
+          <a:lstStyle/>
+          <a:p>
+            <a:pPr algn="r" indent="0" marL="0">
+              <a:buNone/>
+            </a:pPr>
+            <a:r>
+              <a:rPr lang="en-US" sz="1200" b="1" dirty="0">
+                <a:solidFill>
+                  <a:schemeClr val="tx2"/>
+                </a:solidFill>
+              </a:rPr>
+              <a:t>モダン</a:t>
+            </a:r>
+            <a:endParaRPr lang="en-US" sz="1200" dirty="0"/>
+          </a:p>
+        </p:txBody>
+      </p:sp>
+      <p:sp>
+        <p:nvSpPr>
+          <p:cNvPr id="9" name="Text 7"/>
+          <p:cNvSpPr txBox="1"/>
+          <p:nvPr/>
+        </p:nvSpPr>
+        <p:spPr>
+          <a:xfrm>
+            <a:off x="4663440" y="1124712"/>
+            <a:ext cx="2743200" cy="274320"/>
+          </a:xfrm>
+          <a:prstGeom prst="rect">
+            <a:avLst/>
+          </a:prstGeom>
+          <a:noFill/>
+          <a:ln/>
+        </p:spPr>
+        <p:txBody>
+          <a:bodyPr wrap="square" lIns="0" tIns="0" rIns="0" bIns="0" rtlCol="0" anchor="ctr"/>
+          <a:lstStyle/>
+          <a:p>
+            <a:pPr algn="l" indent="0" marL="0">
+              <a:buNone/>
+            </a:pPr>
+            <a:r>
+              <a:rPr lang="en-US" sz="1200" b="1" dirty="0">
+                <a:solidFill>
+                  <a:schemeClr val="tx2"/>
+                </a:solidFill>
+              </a:rPr>
+              <a:t>軽い（淡い色・細い脚）</a:t>
+            </a:r>
+            <a:endParaRPr lang="en-US" sz="1200" dirty="0"/>
+          </a:p>
+        </p:txBody>
+      </p:sp>
+      <p:sp>
+        <p:nvSpPr>
+          <p:cNvPr id="10" name="Text 8"/>
+          <p:cNvSpPr txBox="1"/>
+          <p:nvPr/>
+        </p:nvSpPr>
+        <p:spPr>
+          <a:xfrm>
+            <a:off x="4663440" y="4270248"/>
+            <a:ext cx="2743200" cy="274320"/>
+          </a:xfrm>
+          <a:prstGeom prst="rect">
+            <a:avLst/>
+          </a:prstGeom>
+          <a:noFill/>
+          <a:ln/>
+        </p:spPr>
+        <p:txBody>
+          <a:bodyPr wrap="square" lIns="0" tIns="0" rIns="0" bIns="0" rtlCol="0" anchor="ctr"/>
+          <a:lstStyle/>
+          <a:p>
+            <a:pPr algn="l" indent="0" marL="0">
+              <a:buNone/>
+            </a:pPr>
+            <a:r>
+              <a:rPr lang="en-US" sz="1200" b="1" dirty="0">
+                <a:solidFill>
+                  <a:schemeClr val="tx2"/>
+                </a:solidFill>
+              </a:rPr>
+              <a:t>重い（濃い色・量感・装飾）</a:t>
+            </a:r>
+            <a:endParaRPr lang="en-US" sz="1200" dirty="0"/>
+          </a:p>
+        </p:txBody>
+      </p:sp>
+      <p:sp>
+        <p:nvSpPr>
+          <p:cNvPr id="11" name="Shape 9"/>
           <p:cNvSpPr/>
           <p:nvPr/>
         </p:nvSpPr>
         <p:spPr>
           <a:xfrm>
-            <a:off x="3246120" y="1188720"/>
-            <a:ext cx="2606040" cy="2743200"/>
+            <a:off x="5303520" y="1554480"/>
+            <a:ext cx="1463040" cy="365760"/>
           </a:xfrm>
           <a:prstGeom prst="roundRect">
             <a:avLst>
-              <a:gd name="adj" fmla="val 4211"/>
+              <a:gd name="adj" fmla="val 50000"/>
             </a:avLst>
           </a:prstGeom>
           <a:solidFill>
-            <a:schemeClr val="bg2"/>
+            <a:schemeClr val="tx2"/>
           </a:solidFill>
-          <a:ln/>
-        </p:spPr>
-      </p:sp>
-      <p:sp>
-        <p:nvSpPr>
-          <p:cNvPr id="10" name="Text 8"/>
-          <p:cNvSpPr txBox="1"/>
-          <p:nvPr/>
-        </p:nvSpPr>
-        <p:spPr>
-          <a:xfrm>
-            <a:off x="3474720" y="1371600"/>
-            <a:ext cx="1371600" cy="274320"/>
-          </a:xfrm>
-          <a:prstGeom prst="rect">
-            <a:avLst/>
-          </a:prstGeom>
-          <a:noFill/>
-          <a:ln/>
-        </p:spPr>
-        <p:txBody>
-          <a:bodyPr wrap="square" lIns="0" tIns="0" rIns="0" bIns="0" rtlCol="0" anchor="ctr"/>
-          <a:lstStyle/>
-          <a:p>
-            <a:pPr indent="0" marL="0">
-              <a:buNone/>
-            </a:pPr>
-            <a:r>
-              <a:rPr lang="en-US" sz="1100" b="1" dirty="0">
-                <a:solidFill>
-                  <a:schemeClr val="accent1"/>
-                </a:solidFill>
-              </a:rPr>
-              <a:t>STEP 2</a:t>
-            </a:r>
-            <a:endParaRPr lang="en-US" sz="1100" dirty="0"/>
-          </a:p>
-        </p:txBody>
-      </p:sp>
-      <p:sp>
-        <p:nvSpPr>
-          <p:cNvPr id="11" name="Text 9"/>
-          <p:cNvSpPr txBox="1"/>
-          <p:nvPr/>
-        </p:nvSpPr>
-        <p:spPr>
-          <a:xfrm>
-            <a:off x="4709160" y="1371600"/>
-            <a:ext cx="914400" cy="274320"/>
-          </a:xfrm>
-          <a:prstGeom prst="rect">
-            <a:avLst/>
-          </a:prstGeom>
-          <a:noFill/>
-          <a:ln/>
-        </p:spPr>
-        <p:txBody>
-          <a:bodyPr wrap="square" lIns="0" tIns="0" rIns="0" bIns="0" rtlCol="0" anchor="ctr"/>
-          <a:lstStyle/>
-          <a:p>
-            <a:pPr algn="r" indent="0" marL="0">
-              <a:buNone/>
-            </a:pPr>
-            <a:r>
-              <a:rPr lang="en-US" sz="1100" dirty="0">
-                <a:solidFill>
-                  <a:schemeClr val="accent6"/>
-                </a:solidFill>
-              </a:rPr>
-              <a:t>10分</a:t>
-            </a:r>
-            <a:endParaRPr lang="en-US" sz="1100" dirty="0"/>
-          </a:p>
-        </p:txBody>
+          <a:ln w="9525">
+            <a:solidFill>
+              <a:schemeClr val="tx2"/>
+            </a:solidFill>
+            <a:prstDash val="solid"/>
+          </a:ln>
+        </p:spPr>
       </p:sp>
       <p:sp>
         <p:nvSpPr>
@@ -6713,8 +6784,8 @@
         </p:nvSpPr>
         <p:spPr>
           <a:xfrm>
-            <a:off x="3474720" y="1737360"/>
-            <a:ext cx="2148840" cy="457200"/>
+            <a:off x="5303520" y="1554480"/>
+            <a:ext cx="1463040" cy="365760"/>
           </a:xfrm>
           <a:prstGeom prst="rect">
             <a:avLst/>
@@ -6726,89 +6797,58 @@
           <a:bodyPr wrap="square" lIns="0" tIns="0" rIns="0" bIns="0" rtlCol="0" anchor="ctr"/>
           <a:lstStyle/>
           <a:p>
-            <a:pPr indent="0" marL="0">
-              <a:buNone/>
-            </a:pPr>
-            <a:r>
-              <a:rPr lang="en-US" sz="2000" b="1" dirty="0">
-                <a:solidFill>
-                  <a:schemeClr val="tx2"/>
-                </a:solidFill>
-              </a:rPr>
-              <a:t>置く</a:t>
-            </a:r>
-            <a:endParaRPr lang="en-US" sz="2000" dirty="0"/>
-          </a:p>
-        </p:txBody>
-      </p:sp>
-      <p:sp>
-        <p:nvSpPr>
-          <p:cNvPr id="13" name="Text 11"/>
-          <p:cNvSpPr txBox="1"/>
-          <p:nvPr/>
-        </p:nvSpPr>
-        <p:spPr>
-          <a:xfrm>
-            <a:off x="3474720" y="2331720"/>
-            <a:ext cx="2148840" cy="1463040"/>
-          </a:xfrm>
-          <a:prstGeom prst="rect">
-            <a:avLst/>
-          </a:prstGeom>
-          <a:noFill/>
-          <a:ln/>
-        </p:spPr>
-        <p:txBody>
-          <a:bodyPr wrap="square" lIns="0" tIns="0" rIns="0" bIns="0" rtlCol="0" anchor="t"/>
-          <a:lstStyle/>
-          <a:p>
-            <a:pPr indent="0" marL="0">
-              <a:buNone/>
-            </a:pPr>
-            <a:r>
-              <a:rPr lang="en-US" sz="1300" dirty="0">
-                <a:solidFill>
-                  <a:schemeClr val="tx1"/>
-                </a:solidFill>
-              </a:rPr>
-              <a:t>マトリックスに付箋を貼る。北欧と言っている商品はどこに来るか</a:t>
-            </a:r>
-            <a:endParaRPr lang="en-US" sz="1300" dirty="0"/>
-          </a:p>
-        </p:txBody>
-      </p:sp>
-      <p:sp>
-        <p:nvSpPr>
-          <p:cNvPr id="14" name="step-2"/>
+            <a:pPr algn="ctr" indent="0" marL="0">
+              <a:buNone/>
+            </a:pPr>
+            <a:r>
+              <a:rPr lang="en-US" sz="1100" b="1" dirty="0">
+                <a:solidFill>
+                  <a:schemeClr val="bg1"/>
+                </a:solidFill>
+              </a:rPr>
+              <a:t>北欧モダン</a:t>
+            </a:r>
+            <a:endParaRPr lang="en-US" sz="1100" dirty="0"/>
+          </a:p>
+        </p:txBody>
+      </p:sp>
+      <p:sp>
+        <p:nvSpPr>
+          <p:cNvPr id="13" name="Shape 11"/>
           <p:cNvSpPr/>
           <p:nvPr/>
         </p:nvSpPr>
         <p:spPr>
           <a:xfrm>
-            <a:off x="6035040" y="1188720"/>
-            <a:ext cx="2606040" cy="2743200"/>
+            <a:off x="6035040" y="2103120"/>
+            <a:ext cx="1463040" cy="365760"/>
           </a:xfrm>
           <a:prstGeom prst="roundRect">
             <a:avLst>
-              <a:gd name="adj" fmla="val 4211"/>
+              <a:gd name="adj" fmla="val 50000"/>
             </a:avLst>
           </a:prstGeom>
           <a:solidFill>
-            <a:schemeClr val="bg2"/>
+            <a:schemeClr val="bg1"/>
           </a:solidFill>
-          <a:ln/>
-        </p:spPr>
-      </p:sp>
-      <p:sp>
-        <p:nvSpPr>
-          <p:cNvPr id="15" name="Text 13"/>
+          <a:ln w="9525">
+            <a:solidFill>
+              <a:schemeClr val="accent6"/>
+            </a:solidFill>
+            <a:prstDash val="dash"/>
+          </a:ln>
+        </p:spPr>
+      </p:sp>
+      <p:sp>
+        <p:nvSpPr>
+          <p:cNvPr id="14" name="Text 12"/>
           <p:cNvSpPr txBox="1"/>
           <p:nvPr/>
         </p:nvSpPr>
         <p:spPr>
           <a:xfrm>
-            <a:off x="6263640" y="1371600"/>
-            <a:ext cx="1371600" cy="274320"/>
+            <a:off x="6035040" y="2103120"/>
+            <a:ext cx="1463040" cy="365760"/>
           </a:xfrm>
           <a:prstGeom prst="rect">
             <a:avLst/>
@@ -6820,20 +6860,47 @@
           <a:bodyPr wrap="square" lIns="0" tIns="0" rIns="0" bIns="0" rtlCol="0" anchor="ctr"/>
           <a:lstStyle/>
           <a:p>
-            <a:pPr indent="0" marL="0">
-              <a:buNone/>
-            </a:pPr>
-            <a:r>
-              <a:rPr lang="en-US" sz="1100" b="1" dirty="0">
-                <a:solidFill>
-                  <a:schemeClr val="accent1"/>
-                </a:solidFill>
-              </a:rPr>
-              <a:t>STEP 3</a:t>
+            <a:pPr algn="ctr" indent="0" marL="0">
+              <a:buNone/>
+            </a:pPr>
+            <a:r>
+              <a:rPr lang="en-US" sz="1100" dirty="0">
+                <a:solidFill>
+                  <a:schemeClr val="tx1"/>
+                </a:solidFill>
+              </a:rPr>
+              <a:t>ナチュラル</a:t>
             </a:r>
             <a:endParaRPr lang="en-US" sz="1100" dirty="0"/>
           </a:p>
         </p:txBody>
+      </p:sp>
+      <p:sp>
+        <p:nvSpPr>
+          <p:cNvPr id="15" name="Shape 13"/>
+          <p:cNvSpPr/>
+          <p:nvPr/>
+        </p:nvSpPr>
+        <p:spPr>
+          <a:xfrm>
+            <a:off x="5303520" y="3337560"/>
+            <a:ext cx="1463040" cy="365760"/>
+          </a:xfrm>
+          <a:prstGeom prst="roundRect">
+            <a:avLst>
+              <a:gd name="adj" fmla="val 50000"/>
+            </a:avLst>
+          </a:prstGeom>
+          <a:solidFill>
+            <a:schemeClr val="bg1"/>
+          </a:solidFill>
+          <a:ln w="9525">
+            <a:solidFill>
+              <a:schemeClr val="accent6"/>
+            </a:solidFill>
+            <a:prstDash val="dash"/>
+          </a:ln>
+        </p:spPr>
       </p:sp>
       <p:sp>
         <p:nvSpPr>
@@ -6843,8 +6910,8 @@
         </p:nvSpPr>
         <p:spPr>
           <a:xfrm>
-            <a:off x="7498080" y="1371600"/>
-            <a:ext cx="914400" cy="274320"/>
+            <a:off x="5303520" y="3337560"/>
+            <a:ext cx="1463040" cy="365760"/>
           </a:xfrm>
           <a:prstGeom prst="rect">
             <a:avLst/>
@@ -6856,16 +6923,16 @@
           <a:bodyPr wrap="square" lIns="0" tIns="0" rIns="0" bIns="0" rtlCol="0" anchor="ctr"/>
           <a:lstStyle/>
           <a:p>
-            <a:pPr algn="r" indent="0" marL="0">
+            <a:pPr algn="ctr" indent="0" marL="0">
               <a:buNone/>
             </a:pPr>
             <a:r>
               <a:rPr lang="en-US" sz="1100" dirty="0">
                 <a:solidFill>
-                  <a:schemeClr val="accent6"/>
-                </a:solidFill>
-              </a:rPr>
-              <a:t>5分</a:t>
+                  <a:schemeClr val="tx1"/>
+                </a:solidFill>
+              </a:rPr>
+              <a:t>インダストリアル</a:t>
             </a:r>
             <a:endParaRPr lang="en-US" sz="1100" dirty="0"/>
           </a:p>
@@ -6873,39 +6940,30 @@
       </p:sp>
       <p:sp>
         <p:nvSpPr>
-          <p:cNvPr id="17" name="Text 15"/>
-          <p:cNvSpPr txBox="1"/>
-          <p:nvPr/>
-        </p:nvSpPr>
-        <p:spPr>
-          <a:xfrm>
-            <a:off x="6263640" y="1737360"/>
-            <a:ext cx="2148840" cy="457200"/>
-          </a:xfrm>
-          <a:prstGeom prst="rect">
-            <a:avLst/>
-          </a:prstGeom>
-          <a:noFill/>
-          <a:ln/>
-        </p:spPr>
-        <p:txBody>
-          <a:bodyPr wrap="square" lIns="0" tIns="0" rIns="0" bIns="0" rtlCol="0" anchor="ctr"/>
-          <a:lstStyle/>
-          <a:p>
-            <a:pPr indent="0" marL="0">
-              <a:buNone/>
-            </a:pPr>
-            <a:r>
-              <a:rPr lang="en-US" sz="2000" b="1" dirty="0">
-                <a:solidFill>
-                  <a:schemeClr val="tx2"/>
-                </a:solidFill>
-              </a:rPr>
-              <a:t>気づく</a:t>
-            </a:r>
-            <a:endParaRPr lang="en-US" sz="2000" dirty="0"/>
-          </a:p>
-        </p:txBody>
+          <p:cNvPr id="17" name="Shape 15"/>
+          <p:cNvSpPr/>
+          <p:nvPr/>
+        </p:nvSpPr>
+        <p:spPr>
+          <a:xfrm>
+            <a:off x="6035040" y="3886200"/>
+            <a:ext cx="1463040" cy="365760"/>
+          </a:xfrm>
+          <a:prstGeom prst="roundRect">
+            <a:avLst>
+              <a:gd name="adj" fmla="val 50000"/>
+            </a:avLst>
+          </a:prstGeom>
+          <a:solidFill>
+            <a:schemeClr val="bg1"/>
+          </a:solidFill>
+          <a:ln w="9525">
+            <a:solidFill>
+              <a:schemeClr val="accent6"/>
+            </a:solidFill>
+            <a:prstDash val="dash"/>
+          </a:ln>
+        </p:spPr>
       </p:sp>
       <p:sp>
         <p:nvSpPr>
@@ -6915,67 +6973,319 @@
         </p:nvSpPr>
         <p:spPr>
           <a:xfrm>
-            <a:off x="6263640" y="2331720"/>
-            <a:ext cx="2148840" cy="1463040"/>
-          </a:xfrm>
-          <a:prstGeom prst="rect">
-            <a:avLst/>
-          </a:prstGeom>
-          <a:noFill/>
-          <a:ln/>
-        </p:spPr>
-        <p:txBody>
-          <a:bodyPr wrap="square" lIns="0" tIns="0" rIns="0" bIns="0" rtlCol="0" anchor="t"/>
+            <a:off x="6035040" y="3886200"/>
+            <a:ext cx="1463040" cy="365760"/>
+          </a:xfrm>
+          <a:prstGeom prst="rect">
+            <a:avLst/>
+          </a:prstGeom>
+          <a:noFill/>
+          <a:ln/>
+        </p:spPr>
+        <p:txBody>
+          <a:bodyPr wrap="square" lIns="0" tIns="0" rIns="0" bIns="0" rtlCol="0" anchor="ctr"/>
+          <a:lstStyle/>
+          <a:p>
+            <a:pPr algn="ctr" indent="0" marL="0">
+              <a:buNone/>
+            </a:pPr>
+            <a:r>
+              <a:rPr lang="en-US" sz="1100" dirty="0">
+                <a:solidFill>
+                  <a:schemeClr val="tx1"/>
+                </a:solidFill>
+              </a:rPr>
+              <a:t>イタリアンモダン</a:t>
+            </a:r>
+            <a:endParaRPr lang="en-US" sz="1100" dirty="0"/>
+          </a:p>
+        </p:txBody>
+      </p:sp>
+      <p:sp>
+        <p:nvSpPr>
+          <p:cNvPr id="19" name="Shape 17"/>
+          <p:cNvSpPr/>
+          <p:nvPr/>
+        </p:nvSpPr>
+        <p:spPr>
+          <a:xfrm>
+            <a:off x="1828800" y="1554480"/>
+            <a:ext cx="1463040" cy="365760"/>
+          </a:xfrm>
+          <a:prstGeom prst="roundRect">
+            <a:avLst>
+              <a:gd name="adj" fmla="val 50000"/>
+            </a:avLst>
+          </a:prstGeom>
+          <a:solidFill>
+            <a:schemeClr val="bg1"/>
+          </a:solidFill>
+          <a:ln w="9525">
+            <a:solidFill>
+              <a:schemeClr val="accent6"/>
+            </a:solidFill>
+            <a:prstDash val="dash"/>
+          </a:ln>
+        </p:spPr>
+      </p:sp>
+      <p:sp>
+        <p:nvSpPr>
+          <p:cNvPr id="20" name="Text 18"/>
+          <p:cNvSpPr txBox="1"/>
+          <p:nvPr/>
+        </p:nvSpPr>
+        <p:spPr>
+          <a:xfrm>
+            <a:off x="1828800" y="1554480"/>
+            <a:ext cx="1463040" cy="365760"/>
+          </a:xfrm>
+          <a:prstGeom prst="rect">
+            <a:avLst/>
+          </a:prstGeom>
+          <a:noFill/>
+          <a:ln/>
+        </p:spPr>
+        <p:txBody>
+          <a:bodyPr wrap="square" lIns="0" tIns="0" rIns="0" bIns="0" rtlCol="0" anchor="ctr"/>
+          <a:lstStyle/>
+          <a:p>
+            <a:pPr algn="ctr" indent="0" marL="0">
+              <a:buNone/>
+            </a:pPr>
+            <a:r>
+              <a:rPr lang="en-US" sz="1100" dirty="0">
+                <a:solidFill>
+                  <a:schemeClr val="tx1"/>
+                </a:solidFill>
+              </a:rPr>
+              <a:t>フレンチカントリー</a:t>
+            </a:r>
+            <a:endParaRPr lang="en-US" sz="1100" dirty="0"/>
+          </a:p>
+        </p:txBody>
+      </p:sp>
+      <p:sp>
+        <p:nvSpPr>
+          <p:cNvPr id="21" name="Shape 19"/>
+          <p:cNvSpPr/>
+          <p:nvPr/>
+        </p:nvSpPr>
+        <p:spPr>
+          <a:xfrm>
+            <a:off x="2377440" y="2103120"/>
+            <a:ext cx="1463040" cy="365760"/>
+          </a:xfrm>
+          <a:prstGeom prst="roundRect">
+            <a:avLst>
+              <a:gd name="adj" fmla="val 50000"/>
+            </a:avLst>
+          </a:prstGeom>
+          <a:solidFill>
+            <a:schemeClr val="bg1"/>
+          </a:solidFill>
+          <a:ln w="9525">
+            <a:solidFill>
+              <a:schemeClr val="accent6"/>
+            </a:solidFill>
+            <a:prstDash val="dash"/>
+          </a:ln>
+        </p:spPr>
+      </p:sp>
+      <p:sp>
+        <p:nvSpPr>
+          <p:cNvPr id="22" name="Text 20"/>
+          <p:cNvSpPr txBox="1"/>
+          <p:nvPr/>
+        </p:nvSpPr>
+        <p:spPr>
+          <a:xfrm>
+            <a:off x="2377440" y="2103120"/>
+            <a:ext cx="1463040" cy="365760"/>
+          </a:xfrm>
+          <a:prstGeom prst="rect">
+            <a:avLst/>
+          </a:prstGeom>
+          <a:noFill/>
+          <a:ln/>
+        </p:spPr>
+        <p:txBody>
+          <a:bodyPr wrap="square" lIns="0" tIns="0" rIns="0" bIns="0" rtlCol="0" anchor="ctr"/>
+          <a:lstStyle/>
+          <a:p>
+            <a:pPr algn="ctr" indent="0" marL="0">
+              <a:buNone/>
+            </a:pPr>
+            <a:r>
+              <a:rPr lang="en-US" sz="1100" dirty="0">
+                <a:solidFill>
+                  <a:schemeClr val="tx1"/>
+                </a:solidFill>
+              </a:rPr>
+              <a:t>ロココ</a:t>
+            </a:r>
+            <a:endParaRPr lang="en-US" sz="1100" dirty="0"/>
+          </a:p>
+        </p:txBody>
+      </p:sp>
+      <p:sp>
+        <p:nvSpPr>
+          <p:cNvPr id="23" name="Shape 21"/>
+          <p:cNvSpPr/>
+          <p:nvPr/>
+        </p:nvSpPr>
+        <p:spPr>
+          <a:xfrm>
+            <a:off x="1828800" y="3337560"/>
+            <a:ext cx="1463040" cy="365760"/>
+          </a:xfrm>
+          <a:prstGeom prst="roundRect">
+            <a:avLst>
+              <a:gd name="adj" fmla="val 50000"/>
+            </a:avLst>
+          </a:prstGeom>
+          <a:solidFill>
+            <a:schemeClr val="bg1"/>
+          </a:solidFill>
+          <a:ln w="9525">
+            <a:solidFill>
+              <a:schemeClr val="accent6"/>
+            </a:solidFill>
+            <a:prstDash val="dash"/>
+          </a:ln>
+        </p:spPr>
+      </p:sp>
+      <p:sp>
+        <p:nvSpPr>
+          <p:cNvPr id="24" name="Text 22"/>
+          <p:cNvSpPr txBox="1"/>
+          <p:nvPr/>
+        </p:nvSpPr>
+        <p:spPr>
+          <a:xfrm>
+            <a:off x="1828800" y="3337560"/>
+            <a:ext cx="1463040" cy="365760"/>
+          </a:xfrm>
+          <a:prstGeom prst="rect">
+            <a:avLst/>
+          </a:prstGeom>
+          <a:noFill/>
+          <a:ln/>
+        </p:spPr>
+        <p:txBody>
+          <a:bodyPr wrap="square" lIns="0" tIns="0" rIns="0" bIns="0" rtlCol="0" anchor="ctr"/>
+          <a:lstStyle/>
+          <a:p>
+            <a:pPr algn="ctr" indent="0" marL="0">
+              <a:buNone/>
+            </a:pPr>
+            <a:r>
+              <a:rPr lang="en-US" sz="1100" dirty="0">
+                <a:solidFill>
+                  <a:schemeClr val="tx1"/>
+                </a:solidFill>
+              </a:rPr>
+              <a:t>ヴィクトリアン</a:t>
+            </a:r>
+            <a:endParaRPr lang="en-US" sz="1100" dirty="0"/>
+          </a:p>
+        </p:txBody>
+      </p:sp>
+      <p:sp>
+        <p:nvSpPr>
+          <p:cNvPr id="25" name="Shape 23"/>
+          <p:cNvSpPr/>
+          <p:nvPr/>
+        </p:nvSpPr>
+        <p:spPr>
+          <a:xfrm>
+            <a:off x="2377440" y="3886200"/>
+            <a:ext cx="1463040" cy="365760"/>
+          </a:xfrm>
+          <a:prstGeom prst="roundRect">
+            <a:avLst>
+              <a:gd name="adj" fmla="val 50000"/>
+            </a:avLst>
+          </a:prstGeom>
+          <a:solidFill>
+            <a:schemeClr val="bg1"/>
+          </a:solidFill>
+          <a:ln w="9525">
+            <a:solidFill>
+              <a:schemeClr val="accent6"/>
+            </a:solidFill>
+            <a:prstDash val="dash"/>
+          </a:ln>
+        </p:spPr>
+      </p:sp>
+      <p:sp>
+        <p:nvSpPr>
+          <p:cNvPr id="26" name="Text 24"/>
+          <p:cNvSpPr txBox="1"/>
+          <p:nvPr/>
+        </p:nvSpPr>
+        <p:spPr>
+          <a:xfrm>
+            <a:off x="2377440" y="3886200"/>
+            <a:ext cx="1463040" cy="365760"/>
+          </a:xfrm>
+          <a:prstGeom prst="rect">
+            <a:avLst/>
+          </a:prstGeom>
+          <a:noFill/>
+          <a:ln/>
+        </p:spPr>
+        <p:txBody>
+          <a:bodyPr wrap="square" lIns="0" tIns="0" rIns="0" bIns="0" rtlCol="0" anchor="ctr"/>
+          <a:lstStyle/>
+          <a:p>
+            <a:pPr algn="ctr" indent="0" marL="0">
+              <a:buNone/>
+            </a:pPr>
+            <a:r>
+              <a:rPr lang="en-US" sz="1100" dirty="0">
+                <a:solidFill>
+                  <a:schemeClr val="tx1"/>
+                </a:solidFill>
+              </a:rPr>
+              <a:t>バロック</a:t>
+            </a:r>
+            <a:endParaRPr lang="en-US" sz="1100" dirty="0"/>
+          </a:p>
+        </p:txBody>
+      </p:sp>
+      <p:sp>
+        <p:nvSpPr>
+          <p:cNvPr id="27" name="Text 25"/>
+          <p:cNvSpPr txBox="1"/>
+          <p:nvPr/>
+        </p:nvSpPr>
+        <p:spPr>
+          <a:xfrm>
+            <a:off x="457200" y="4709160"/>
+            <a:ext cx="5486400" cy="274320"/>
+          </a:xfrm>
+          <a:prstGeom prst="rect">
+            <a:avLst/>
+          </a:prstGeom>
+          <a:noFill/>
+          <a:ln/>
+        </p:spPr>
+        <p:txBody>
+          <a:bodyPr wrap="square" lIns="0" tIns="0" rIns="0" bIns="0" rtlCol="0" anchor="ctr"/>
           <a:lstStyle/>
           <a:p>
             <a:pPr indent="0" marL="0">
               <a:buNone/>
             </a:pPr>
             <a:r>
-              <a:rPr lang="en-US" sz="1300" dirty="0">
-                <a:solidFill>
-                  <a:schemeClr val="tx1"/>
-                </a:solidFill>
-              </a:rPr>
-              <a:t>眺めて共有。「北欧のつもりがばらけている」「この象限が空いている」</a:t>
-            </a:r>
-            <a:endParaRPr lang="en-US" sz="1300" dirty="0"/>
-          </a:p>
-        </p:txBody>
-      </p:sp>
-      <p:sp>
-        <p:nvSpPr>
-          <p:cNvPr id="19" name="Text 17"/>
-          <p:cNvSpPr txBox="1"/>
-          <p:nvPr/>
-        </p:nvSpPr>
-        <p:spPr>
-          <a:xfrm>
-            <a:off x="457200" y="4160520"/>
-            <a:ext cx="8229600" cy="320040"/>
-          </a:xfrm>
-          <a:prstGeom prst="rect">
-            <a:avLst/>
-          </a:prstGeom>
-          <a:noFill/>
-          <a:ln/>
-        </p:spPr>
-        <p:txBody>
-          <a:bodyPr wrap="square" lIns="0" tIns="0" rIns="0" bIns="0" rtlCol="0" anchor="ctr"/>
-          <a:lstStyle/>
-          <a:p>
-            <a:pPr indent="0" marL="0">
-              <a:buNone/>
-            </a:pPr>
-            <a:r>
-              <a:rPr lang="en-US" sz="1200" dirty="0">
+              <a:rPr lang="en-US" sz="1000" dirty="0">
                 <a:solidFill>
                   <a:schemeClr val="accent6"/>
                 </a:solidFill>
               </a:rPr>
-              <a:t>素材例：リビングの商品リスト（product_list_living.xlsx）</a:t>
-            </a:r>
-            <a:endParaRPr lang="en-US" sz="1200" dirty="0"/>
+              <a:t>点線は位置の例（当日の議論で動かしてOK）</a:t>
+            </a:r>
+            <a:endParaRPr lang="en-US" sz="1000" dirty="0"/>
           </a:p>
         </p:txBody>
       </p:sp>
@@ -7035,6 +7345,684 @@
 <file path=ppt/slides/slide15.xml><?xml version="1.0" encoding="utf-8"?>
 <p:sld xmlns:a="http://schemas.openxmlformats.org/drawingml/2006/main" xmlns:r="http://schemas.openxmlformats.org/officeDocument/2006/relationships" xmlns:p="http://schemas.openxmlformats.org/presentationml/2006/main">
   <p:cSld name="Slide 15">
+    <p:spTree>
+      <p:nvGrpSpPr>
+        <p:cNvPr id="1" name=""/>
+        <p:cNvGrpSpPr/>
+        <p:nvPr/>
+      </p:nvGrpSpPr>
+      <p:grpSpPr>
+        <a:xfrm>
+          <a:off x="0" y="0"/>
+          <a:ext cx="0" cy="0"/>
+          <a:chOff x="0" y="0"/>
+          <a:chExt cx="0" cy="0"/>
+        </a:xfrm>
+      </p:grpSpPr>
+      <p:sp>
+        <p:nvSpPr>
+          <p:cNvPr id="2" name="part-tag"/>
+          <p:cNvSpPr txBox="1"/>
+          <p:nvPr/>
+        </p:nvSpPr>
+        <p:spPr>
+          <a:xfrm>
+            <a:off x="457200" y="73152"/>
+            <a:ext cx="3657600" cy="228600"/>
+          </a:xfrm>
+          <a:prstGeom prst="rect">
+            <a:avLst/>
+          </a:prstGeom>
+          <a:noFill/>
+          <a:ln/>
+        </p:spPr>
+        <p:txBody>
+          <a:bodyPr wrap="square" lIns="0" tIns="0" rIns="0" bIns="0" rtlCol="0" anchor="ctr"/>
+          <a:lstStyle/>
+          <a:p>
+            <a:pPr indent="0" marL="0">
+              <a:buNone/>
+            </a:pPr>
+            <a:r>
+              <a:rPr lang="en-US" sz="1100" b="1" dirty="0">
+                <a:solidFill>
+                  <a:schemeClr val="accent1"/>
+                </a:solidFill>
+              </a:rPr>
+              <a:t>⑤ グループワーク</a:t>
+            </a:r>
+            <a:endParaRPr lang="en-US" sz="1100" dirty="0"/>
+          </a:p>
+        </p:txBody>
+      </p:sp>
+      <p:sp>
+        <p:nvSpPr>
+          <p:cNvPr id="3" name="Text 0"/>
+          <p:cNvSpPr/>
+          <p:nvPr>
+            <p:ph idx="100" type="title" hasCustomPrompt="1"/>
+          </p:nvPr>
+        </p:nvSpPr>
+        <p:spPr>
+          <a:xfrm>
+            <a:off x="457200" y="274320"/>
+            <a:ext cx="8229600" cy="640080"/>
+          </a:xfrm>
+          <a:prstGeom prst="rect">
+            <a:avLst/>
+          </a:prstGeom>
+          <a:noFill/>
+          <a:ln/>
+        </p:spPr>
+        <p:txBody>
+          <a:bodyPr wrap="square" lIns="0" tIns="0" rIns="0" bIns="0" rtlCol="0" anchor="ctr"/>
+          <a:lstStyle/>
+          <a:p>
+            <a:pPr algn="l" indent="0" marL="0">
+              <a:buNone/>
+            </a:pPr>
+            <a:r>
+              <a:rPr lang="en-US" sz="2600" b="1" dirty="0">
+                <a:solidFill>
+                  <a:schemeClr val="tx2"/>
+                </a:solidFill>
+              </a:rPr>
+              <a:t>ワークの進め方</a:t>
+            </a:r>
+            <a:endParaRPr lang="en-US" sz="2600" dirty="0"/>
+          </a:p>
+        </p:txBody>
+      </p:sp>
+      <p:sp>
+        <p:nvSpPr>
+          <p:cNvPr id="4" name="step-0"/>
+          <p:cNvSpPr/>
+          <p:nvPr/>
+        </p:nvSpPr>
+        <p:spPr>
+          <a:xfrm>
+            <a:off x="457200" y="1188720"/>
+            <a:ext cx="2606040" cy="2743200"/>
+          </a:xfrm>
+          <a:prstGeom prst="roundRect">
+            <a:avLst>
+              <a:gd name="adj" fmla="val 4211"/>
+            </a:avLst>
+          </a:prstGeom>
+          <a:solidFill>
+            <a:schemeClr val="bg2"/>
+          </a:solidFill>
+          <a:ln/>
+        </p:spPr>
+      </p:sp>
+      <p:sp>
+        <p:nvSpPr>
+          <p:cNvPr id="5" name="Text 3"/>
+          <p:cNvSpPr txBox="1"/>
+          <p:nvPr/>
+        </p:nvSpPr>
+        <p:spPr>
+          <a:xfrm>
+            <a:off x="685800" y="1371600"/>
+            <a:ext cx="1371600" cy="274320"/>
+          </a:xfrm>
+          <a:prstGeom prst="rect">
+            <a:avLst/>
+          </a:prstGeom>
+          <a:noFill/>
+          <a:ln/>
+        </p:spPr>
+        <p:txBody>
+          <a:bodyPr wrap="square" lIns="0" tIns="0" rIns="0" bIns="0" rtlCol="0" anchor="ctr"/>
+          <a:lstStyle/>
+          <a:p>
+            <a:pPr indent="0" marL="0">
+              <a:buNone/>
+            </a:pPr>
+            <a:r>
+              <a:rPr lang="en-US" sz="1100" b="1" dirty="0">
+                <a:solidFill>
+                  <a:schemeClr val="accent1"/>
+                </a:solidFill>
+              </a:rPr>
+              <a:t>STEP 1</a:t>
+            </a:r>
+            <a:endParaRPr lang="en-US" sz="1100" dirty="0"/>
+          </a:p>
+        </p:txBody>
+      </p:sp>
+      <p:sp>
+        <p:nvSpPr>
+          <p:cNvPr id="6" name="Text 4"/>
+          <p:cNvSpPr txBox="1"/>
+          <p:nvPr/>
+        </p:nvSpPr>
+        <p:spPr>
+          <a:xfrm>
+            <a:off x="1920240" y="1371600"/>
+            <a:ext cx="914400" cy="274320"/>
+          </a:xfrm>
+          <a:prstGeom prst="rect">
+            <a:avLst/>
+          </a:prstGeom>
+          <a:noFill/>
+          <a:ln/>
+        </p:spPr>
+        <p:txBody>
+          <a:bodyPr wrap="square" lIns="0" tIns="0" rIns="0" bIns="0" rtlCol="0" anchor="ctr"/>
+          <a:lstStyle/>
+          <a:p>
+            <a:pPr algn="r" indent="0" marL="0">
+              <a:buNone/>
+            </a:pPr>
+            <a:r>
+              <a:rPr lang="en-US" sz="1100" dirty="0">
+                <a:solidFill>
+                  <a:schemeClr val="accent6"/>
+                </a:solidFill>
+              </a:rPr>
+              <a:t>10分</a:t>
+            </a:r>
+            <a:endParaRPr lang="en-US" sz="1100" dirty="0"/>
+          </a:p>
+        </p:txBody>
+      </p:sp>
+      <p:sp>
+        <p:nvSpPr>
+          <p:cNvPr id="7" name="Text 5"/>
+          <p:cNvSpPr txBox="1"/>
+          <p:nvPr/>
+        </p:nvSpPr>
+        <p:spPr>
+          <a:xfrm>
+            <a:off x="685800" y="1737360"/>
+            <a:ext cx="2148840" cy="457200"/>
+          </a:xfrm>
+          <a:prstGeom prst="rect">
+            <a:avLst/>
+          </a:prstGeom>
+          <a:noFill/>
+          <a:ln/>
+        </p:spPr>
+        <p:txBody>
+          <a:bodyPr wrap="square" lIns="0" tIns="0" rIns="0" bIns="0" rtlCol="0" anchor="ctr"/>
+          <a:lstStyle/>
+          <a:p>
+            <a:pPr indent="0" marL="0">
+              <a:buNone/>
+            </a:pPr>
+            <a:r>
+              <a:rPr lang="en-US" sz="2000" b="1" dirty="0">
+                <a:solidFill>
+                  <a:schemeClr val="tx2"/>
+                </a:solidFill>
+              </a:rPr>
+              <a:t>書き出す</a:t>
+            </a:r>
+            <a:endParaRPr lang="en-US" sz="2000" dirty="0"/>
+          </a:p>
+        </p:txBody>
+      </p:sp>
+      <p:sp>
+        <p:nvSpPr>
+          <p:cNvPr id="8" name="Text 6"/>
+          <p:cNvSpPr txBox="1"/>
+          <p:nvPr/>
+        </p:nvSpPr>
+        <p:spPr>
+          <a:xfrm>
+            <a:off x="685800" y="2331720"/>
+            <a:ext cx="2148840" cy="1463040"/>
+          </a:xfrm>
+          <a:prstGeom prst="rect">
+            <a:avLst/>
+          </a:prstGeom>
+          <a:noFill/>
+          <a:ln/>
+        </p:spPr>
+        <p:txBody>
+          <a:bodyPr wrap="square" lIns="0" tIns="0" rIns="0" bIns="0" rtlCol="0" anchor="t"/>
+          <a:lstStyle/>
+          <a:p>
+            <a:pPr indent="0" marL="0">
+              <a:buNone/>
+            </a:pPr>
+            <a:r>
+              <a:rPr lang="en-US" sz="1300" dirty="0">
+                <a:solidFill>
+                  <a:schemeClr val="tx1"/>
+                </a:solidFill>
+              </a:rPr>
+              <a:t>商品開発部の商品を書き出し、各商品が「どのスタイルか」を付箋に書く</a:t>
+            </a:r>
+            <a:endParaRPr lang="en-US" sz="1300" dirty="0"/>
+          </a:p>
+        </p:txBody>
+      </p:sp>
+      <p:sp>
+        <p:nvSpPr>
+          <p:cNvPr id="9" name="step-1"/>
+          <p:cNvSpPr/>
+          <p:nvPr/>
+        </p:nvSpPr>
+        <p:spPr>
+          <a:xfrm>
+            <a:off x="3246120" y="1188720"/>
+            <a:ext cx="2606040" cy="2743200"/>
+          </a:xfrm>
+          <a:prstGeom prst="roundRect">
+            <a:avLst>
+              <a:gd name="adj" fmla="val 4211"/>
+            </a:avLst>
+          </a:prstGeom>
+          <a:solidFill>
+            <a:schemeClr val="bg2"/>
+          </a:solidFill>
+          <a:ln/>
+        </p:spPr>
+      </p:sp>
+      <p:sp>
+        <p:nvSpPr>
+          <p:cNvPr id="10" name="Text 8"/>
+          <p:cNvSpPr txBox="1"/>
+          <p:nvPr/>
+        </p:nvSpPr>
+        <p:spPr>
+          <a:xfrm>
+            <a:off x="3474720" y="1371600"/>
+            <a:ext cx="1371600" cy="274320"/>
+          </a:xfrm>
+          <a:prstGeom prst="rect">
+            <a:avLst/>
+          </a:prstGeom>
+          <a:noFill/>
+          <a:ln/>
+        </p:spPr>
+        <p:txBody>
+          <a:bodyPr wrap="square" lIns="0" tIns="0" rIns="0" bIns="0" rtlCol="0" anchor="ctr"/>
+          <a:lstStyle/>
+          <a:p>
+            <a:pPr indent="0" marL="0">
+              <a:buNone/>
+            </a:pPr>
+            <a:r>
+              <a:rPr lang="en-US" sz="1100" b="1" dirty="0">
+                <a:solidFill>
+                  <a:schemeClr val="accent1"/>
+                </a:solidFill>
+              </a:rPr>
+              <a:t>STEP 2</a:t>
+            </a:r>
+            <a:endParaRPr lang="en-US" sz="1100" dirty="0"/>
+          </a:p>
+        </p:txBody>
+      </p:sp>
+      <p:sp>
+        <p:nvSpPr>
+          <p:cNvPr id="11" name="Text 9"/>
+          <p:cNvSpPr txBox="1"/>
+          <p:nvPr/>
+        </p:nvSpPr>
+        <p:spPr>
+          <a:xfrm>
+            <a:off x="4709160" y="1371600"/>
+            <a:ext cx="914400" cy="274320"/>
+          </a:xfrm>
+          <a:prstGeom prst="rect">
+            <a:avLst/>
+          </a:prstGeom>
+          <a:noFill/>
+          <a:ln/>
+        </p:spPr>
+        <p:txBody>
+          <a:bodyPr wrap="square" lIns="0" tIns="0" rIns="0" bIns="0" rtlCol="0" anchor="ctr"/>
+          <a:lstStyle/>
+          <a:p>
+            <a:pPr algn="r" indent="0" marL="0">
+              <a:buNone/>
+            </a:pPr>
+            <a:r>
+              <a:rPr lang="en-US" sz="1100" dirty="0">
+                <a:solidFill>
+                  <a:schemeClr val="accent6"/>
+                </a:solidFill>
+              </a:rPr>
+              <a:t>10分</a:t>
+            </a:r>
+            <a:endParaRPr lang="en-US" sz="1100" dirty="0"/>
+          </a:p>
+        </p:txBody>
+      </p:sp>
+      <p:sp>
+        <p:nvSpPr>
+          <p:cNvPr id="12" name="Text 10"/>
+          <p:cNvSpPr txBox="1"/>
+          <p:nvPr/>
+        </p:nvSpPr>
+        <p:spPr>
+          <a:xfrm>
+            <a:off x="3474720" y="1737360"/>
+            <a:ext cx="2148840" cy="457200"/>
+          </a:xfrm>
+          <a:prstGeom prst="rect">
+            <a:avLst/>
+          </a:prstGeom>
+          <a:noFill/>
+          <a:ln/>
+        </p:spPr>
+        <p:txBody>
+          <a:bodyPr wrap="square" lIns="0" tIns="0" rIns="0" bIns="0" rtlCol="0" anchor="ctr"/>
+          <a:lstStyle/>
+          <a:p>
+            <a:pPr indent="0" marL="0">
+              <a:buNone/>
+            </a:pPr>
+            <a:r>
+              <a:rPr lang="en-US" sz="2000" b="1" dirty="0">
+                <a:solidFill>
+                  <a:schemeClr val="tx2"/>
+                </a:solidFill>
+              </a:rPr>
+              <a:t>置く</a:t>
+            </a:r>
+            <a:endParaRPr lang="en-US" sz="2000" dirty="0"/>
+          </a:p>
+        </p:txBody>
+      </p:sp>
+      <p:sp>
+        <p:nvSpPr>
+          <p:cNvPr id="13" name="Text 11"/>
+          <p:cNvSpPr txBox="1"/>
+          <p:nvPr/>
+        </p:nvSpPr>
+        <p:spPr>
+          <a:xfrm>
+            <a:off x="3474720" y="2331720"/>
+            <a:ext cx="2148840" cy="1463040"/>
+          </a:xfrm>
+          <a:prstGeom prst="rect">
+            <a:avLst/>
+          </a:prstGeom>
+          <a:noFill/>
+          <a:ln/>
+        </p:spPr>
+        <p:txBody>
+          <a:bodyPr wrap="square" lIns="0" tIns="0" rIns="0" bIns="0" rtlCol="0" anchor="t"/>
+          <a:lstStyle/>
+          <a:p>
+            <a:pPr indent="0" marL="0">
+              <a:buNone/>
+            </a:pPr>
+            <a:r>
+              <a:rPr lang="en-US" sz="1300" dirty="0">
+                <a:solidFill>
+                  <a:schemeClr val="tx1"/>
+                </a:solidFill>
+              </a:rPr>
+              <a:t>マトリックスに付箋を貼る。北欧と言っている商品はどこに来るか</a:t>
+            </a:r>
+            <a:endParaRPr lang="en-US" sz="1300" dirty="0"/>
+          </a:p>
+        </p:txBody>
+      </p:sp>
+      <p:sp>
+        <p:nvSpPr>
+          <p:cNvPr id="14" name="step-2"/>
+          <p:cNvSpPr/>
+          <p:nvPr/>
+        </p:nvSpPr>
+        <p:spPr>
+          <a:xfrm>
+            <a:off x="6035040" y="1188720"/>
+            <a:ext cx="2606040" cy="2743200"/>
+          </a:xfrm>
+          <a:prstGeom prst="roundRect">
+            <a:avLst>
+              <a:gd name="adj" fmla="val 4211"/>
+            </a:avLst>
+          </a:prstGeom>
+          <a:solidFill>
+            <a:schemeClr val="bg2"/>
+          </a:solidFill>
+          <a:ln/>
+        </p:spPr>
+      </p:sp>
+      <p:sp>
+        <p:nvSpPr>
+          <p:cNvPr id="15" name="Text 13"/>
+          <p:cNvSpPr txBox="1"/>
+          <p:nvPr/>
+        </p:nvSpPr>
+        <p:spPr>
+          <a:xfrm>
+            <a:off x="6263640" y="1371600"/>
+            <a:ext cx="1371600" cy="274320"/>
+          </a:xfrm>
+          <a:prstGeom prst="rect">
+            <a:avLst/>
+          </a:prstGeom>
+          <a:noFill/>
+          <a:ln/>
+        </p:spPr>
+        <p:txBody>
+          <a:bodyPr wrap="square" lIns="0" tIns="0" rIns="0" bIns="0" rtlCol="0" anchor="ctr"/>
+          <a:lstStyle/>
+          <a:p>
+            <a:pPr indent="0" marL="0">
+              <a:buNone/>
+            </a:pPr>
+            <a:r>
+              <a:rPr lang="en-US" sz="1100" b="1" dirty="0">
+                <a:solidFill>
+                  <a:schemeClr val="accent1"/>
+                </a:solidFill>
+              </a:rPr>
+              <a:t>STEP 3</a:t>
+            </a:r>
+            <a:endParaRPr lang="en-US" sz="1100" dirty="0"/>
+          </a:p>
+        </p:txBody>
+      </p:sp>
+      <p:sp>
+        <p:nvSpPr>
+          <p:cNvPr id="16" name="Text 14"/>
+          <p:cNvSpPr txBox="1"/>
+          <p:nvPr/>
+        </p:nvSpPr>
+        <p:spPr>
+          <a:xfrm>
+            <a:off x="7498080" y="1371600"/>
+            <a:ext cx="914400" cy="274320"/>
+          </a:xfrm>
+          <a:prstGeom prst="rect">
+            <a:avLst/>
+          </a:prstGeom>
+          <a:noFill/>
+          <a:ln/>
+        </p:spPr>
+        <p:txBody>
+          <a:bodyPr wrap="square" lIns="0" tIns="0" rIns="0" bIns="0" rtlCol="0" anchor="ctr"/>
+          <a:lstStyle/>
+          <a:p>
+            <a:pPr algn="r" indent="0" marL="0">
+              <a:buNone/>
+            </a:pPr>
+            <a:r>
+              <a:rPr lang="en-US" sz="1100" dirty="0">
+                <a:solidFill>
+                  <a:schemeClr val="accent6"/>
+                </a:solidFill>
+              </a:rPr>
+              <a:t>5分</a:t>
+            </a:r>
+            <a:endParaRPr lang="en-US" sz="1100" dirty="0"/>
+          </a:p>
+        </p:txBody>
+      </p:sp>
+      <p:sp>
+        <p:nvSpPr>
+          <p:cNvPr id="17" name="Text 15"/>
+          <p:cNvSpPr txBox="1"/>
+          <p:nvPr/>
+        </p:nvSpPr>
+        <p:spPr>
+          <a:xfrm>
+            <a:off x="6263640" y="1737360"/>
+            <a:ext cx="2148840" cy="457200"/>
+          </a:xfrm>
+          <a:prstGeom prst="rect">
+            <a:avLst/>
+          </a:prstGeom>
+          <a:noFill/>
+          <a:ln/>
+        </p:spPr>
+        <p:txBody>
+          <a:bodyPr wrap="square" lIns="0" tIns="0" rIns="0" bIns="0" rtlCol="0" anchor="ctr"/>
+          <a:lstStyle/>
+          <a:p>
+            <a:pPr indent="0" marL="0">
+              <a:buNone/>
+            </a:pPr>
+            <a:r>
+              <a:rPr lang="en-US" sz="2000" b="1" dirty="0">
+                <a:solidFill>
+                  <a:schemeClr val="tx2"/>
+                </a:solidFill>
+              </a:rPr>
+              <a:t>気づく</a:t>
+            </a:r>
+            <a:endParaRPr lang="en-US" sz="2000" dirty="0"/>
+          </a:p>
+        </p:txBody>
+      </p:sp>
+      <p:sp>
+        <p:nvSpPr>
+          <p:cNvPr id="18" name="Text 16"/>
+          <p:cNvSpPr txBox="1"/>
+          <p:nvPr/>
+        </p:nvSpPr>
+        <p:spPr>
+          <a:xfrm>
+            <a:off x="6263640" y="2331720"/>
+            <a:ext cx="2148840" cy="1463040"/>
+          </a:xfrm>
+          <a:prstGeom prst="rect">
+            <a:avLst/>
+          </a:prstGeom>
+          <a:noFill/>
+          <a:ln/>
+        </p:spPr>
+        <p:txBody>
+          <a:bodyPr wrap="square" lIns="0" tIns="0" rIns="0" bIns="0" rtlCol="0" anchor="t"/>
+          <a:lstStyle/>
+          <a:p>
+            <a:pPr indent="0" marL="0">
+              <a:buNone/>
+            </a:pPr>
+            <a:r>
+              <a:rPr lang="en-US" sz="1300" dirty="0">
+                <a:solidFill>
+                  <a:schemeClr val="tx1"/>
+                </a:solidFill>
+              </a:rPr>
+              <a:t>眺めて共有。「北欧のつもりがばらけている」「この象限が空いている」</a:t>
+            </a:r>
+            <a:endParaRPr lang="en-US" sz="1300" dirty="0"/>
+          </a:p>
+        </p:txBody>
+      </p:sp>
+      <p:sp>
+        <p:nvSpPr>
+          <p:cNvPr id="19" name="Text 17"/>
+          <p:cNvSpPr txBox="1"/>
+          <p:nvPr/>
+        </p:nvSpPr>
+        <p:spPr>
+          <a:xfrm>
+            <a:off x="457200" y="4160520"/>
+            <a:ext cx="8229600" cy="320040"/>
+          </a:xfrm>
+          <a:prstGeom prst="rect">
+            <a:avLst/>
+          </a:prstGeom>
+          <a:noFill/>
+          <a:ln/>
+        </p:spPr>
+        <p:txBody>
+          <a:bodyPr wrap="square" lIns="0" tIns="0" rIns="0" bIns="0" rtlCol="0" anchor="ctr"/>
+          <a:lstStyle/>
+          <a:p>
+            <a:pPr indent="0" marL="0">
+              <a:buNone/>
+            </a:pPr>
+            <a:r>
+              <a:rPr lang="en-US" sz="1200" dirty="0">
+                <a:solidFill>
+                  <a:schemeClr val="accent6"/>
+                </a:solidFill>
+              </a:rPr>
+              <a:t>素材例：リビングの商品リスト（product_list_living.xlsx）</a:t>
+            </a:r>
+            <a:endParaRPr lang="en-US" sz="1200" dirty="0"/>
+          </a:p>
+        </p:txBody>
+      </p:sp>
+      <p:sp>
+        <p:nvSpPr>
+          <p:cNvPr id="25" name="Slide Number Placeholder 0"/>
+          <p:cNvSpPr>
+            <a:spLocks noGrp="1"/>
+          </p:cNvSpPr>
+          <p:nvPr>
+            <p:ph type="sldNum" sz="quarter" idx="4294967295"/>
+          </p:nvPr>
+        </p:nvSpPr>
+        <p:spPr>
+          <a:xfrm>
+            <a:off x="8412480" y="4754880"/>
+            <a:ext cx="457200" cy="274320"/>
+          </a:xfrm>
+          <a:prstGeom prst="rect">
+            <a:avLst/>
+          </a:prstGeom>
+          <a:extLst>
+            <a:ext uri="{C572A759-6A51-4108-AA02-DFA0A04FC94B}">
+              <ma14:wrappingTextBoxFlag xmlns:ma14="http://schemas.microsoft.com/office/mac/drawingml/2011/main" val="0"/>
+            </a:ext>
+          </a:extLst>
+        </p:spPr>
+        <p:txBody>
+          <a:bodyPr/>
+          <a:lstStyle>
+            <a:lvl1pPr>
+              <a:defRPr sz="1000">
+                <a:solidFill>
+                  <a:schemeClr val="accent6"/>
+                </a:solidFill>
+              </a:defRPr>
+            </a:lvl1pPr>
+          </a:lstStyle>
+          <a:p>
+            <a:pPr algn="l"/>
+            <a:fld id="{F7021451-1387-4CA6-816F-3879F97B5CBC}" type="slidenum">
+              <a:rPr b="0" lang="en-US"/>
+              <a:t>15</a:t>
+            </a:fld>
+            <a:endParaRPr lang="en-US"/>
+          </a:p>
+        </p:txBody>
+      </p:sp>
+    </p:spTree>
+  </p:cSld>
+  <p:clrMapOvr>
+    <a:masterClrMapping/>
+  </p:clrMapOvr>
+</p:sld>
+</file>
+
+<file path=ppt/slides/slide16.xml><?xml version="1.0" encoding="utf-8"?>
+<p:sld xmlns:a="http://schemas.openxmlformats.org/drawingml/2006/main" xmlns:r="http://schemas.openxmlformats.org/officeDocument/2006/relationships" xmlns:p="http://schemas.openxmlformats.org/presentationml/2006/main">
+  <p:cSld name="Slide 16">
     <p:spTree>
       <p:nvGrpSpPr>
         <p:cNvPr id="1" name=""/>

</xml_diff>